<commit_message>
Fix monospace alignment on slides 4-7
Same hand-padding issue as slides 9-11 — labels of varying length with
hardcoded spaces don't align properly, especially when Unicode
superscripts (narrower than regular digits in Consolas) are included.

Fixed by using fixed-width column padding and removing inline
superscripts from monospace data blocks.

Also includes:
- Slide 4: 'From 2019 peak to 2025' subgroup table
- Slide 5: Top/bottom 5 rankings with superscript citations placed
  outside the alignment column
- Slide 6 (new): three-column tier breakdown of 49 districts
- Slide 7: MI affluent peer pre/post Δ + 2025 G4 ELA M-STEP

Co-Authored-By: Claude Opus 4.7 (1M context) <noreply@anthropic.com>
</commit_message>
<xml_diff>
--- a/deck/Troy_K5_ELA_Executive_Summary_v4.pptx
+++ b/deck/Troy_K5_ELA_Executive_Summary_v4.pptx
@@ -26207,85 +26207,109 @@
           <a:p>
             <a:pPr algn="l"/>
             <a:r>
-              <a:rPr sz="1400" b="0" i="0">
+              <a:rPr sz="1300" b="0" i="0">
                 <a:solidFill>
                   <a:srgbClr val="333333"/>
                 </a:solidFill>
                 <a:latin typeface="Consolas"/>
               </a:rPr>
-              <a:t>All Students:  −0.36 grade levels</a:t>
-            </a:r>
-          </a:p>
-          <a:p>
-            <a:pPr algn="l"/>
-            <a:r>
-              <a:rPr sz="1400" b="0" i="0">
+              <a:t>All Students    −0.36</a:t>
+            </a:r>
+          </a:p>
+          <a:p>
+            <a:pPr algn="l"/>
+            <a:r>
+              <a:rPr sz="1300" b="0" i="0">
                 <a:solidFill>
                   <a:srgbClr val="333333"/>
                 </a:solidFill>
                 <a:latin typeface="Consolas"/>
               </a:rPr>
-              <a:t>Asian:                −0.46</a:t>
-            </a:r>
-          </a:p>
-          <a:p>
-            <a:pPr algn="l"/>
-            <a:r>
-              <a:rPr sz="1400" b="0" i="0">
+              <a:t>Asian           −0.46</a:t>
+            </a:r>
+          </a:p>
+          <a:p>
+            <a:pPr algn="l"/>
+            <a:r>
+              <a:rPr sz="1300" b="0" i="0">
                 <a:solidFill>
                   <a:srgbClr val="333333"/>
                 </a:solidFill>
                 <a:latin typeface="Consolas"/>
               </a:rPr>
-              <a:t>White:                 −0.29</a:t>
-            </a:r>
-          </a:p>
-          <a:p>
-            <a:pPr algn="l"/>
-            <a:r>
-              <a:rPr sz="1400" b="0" i="0">
+              <a:t>White           −0.29</a:t>
+            </a:r>
+          </a:p>
+          <a:p>
+            <a:pPr algn="l"/>
+            <a:r>
+              <a:rPr sz="1300" b="0" i="0">
                 <a:solidFill>
                   <a:srgbClr val="333333"/>
                 </a:solidFill>
                 <a:latin typeface="Consolas"/>
               </a:rPr>
-              <a:t>Not-ECD:           −0.37</a:t>
-            </a:r>
-          </a:p>
-          <a:p>
-            <a:pPr algn="l"/>
-            <a:r>
-              <a:rPr sz="1400" b="0" i="0">
+              <a:t>Not-ECD         −0.37</a:t>
+            </a:r>
+          </a:p>
+          <a:p>
+            <a:pPr algn="l"/>
+            <a:r>
+              <a:rPr sz="1300" b="0" i="0">
                 <a:solidFill>
                   <a:srgbClr val="333333"/>
                 </a:solidFill>
                 <a:latin typeface="Consolas"/>
               </a:rPr>
-              <a:t>EconDis:            −0.25</a:t>
-            </a:r>
-          </a:p>
-          <a:p>
-            <a:pPr algn="l"/>
-            <a:r>
-              <a:rPr sz="1400" b="0" i="0">
+              <a:t>EconDis         −0.25</a:t>
+            </a:r>
+          </a:p>
+          <a:p>
+            <a:pPr algn="l"/>
+            <a:r>
+              <a:rPr sz="1300" b="0" i="0">
                 <a:solidFill>
                   <a:srgbClr val="333333"/>
                 </a:solidFill>
                 <a:latin typeface="Consolas"/>
               </a:rPr>
-              <a:t>Hispanic:           −0.10</a:t>
-            </a:r>
-          </a:p>
-          <a:p>
-            <a:pPr algn="l"/>
-            <a:r>
-              <a:rPr sz="1400" b="0" i="0">
+              <a:t>Hispanic        −0.10</a:t>
+            </a:r>
+          </a:p>
+          <a:p>
+            <a:pPr algn="l"/>
+            <a:r>
+              <a:rPr sz="1300" b="0" i="0">
                 <a:solidFill>
                   <a:srgbClr val="333333"/>
                 </a:solidFill>
                 <a:latin typeface="Consolas"/>
               </a:rPr>
-              <a:t>Black:                  −0.15</a:t>
+              <a:t>Black           −0.15</a:t>
+            </a:r>
+          </a:p>
+          <a:p>
+            <a:pPr algn="l"/>
+            <a:r>
+              <a:rPr sz="1300" b="0" i="0">
+                <a:solidFill>
+                  <a:srgbClr val="333333"/>
+                </a:solidFill>
+                <a:latin typeface="Consolas"/>
+              </a:rPr>
+              <a:t/>
+            </a:r>
+          </a:p>
+          <a:p>
+            <a:pPr algn="l"/>
+            <a:r>
+              <a:rPr sz="1300" b="0" i="0">
+                <a:solidFill>
+                  <a:srgbClr val="333333"/>
+                </a:solidFill>
+                <a:latin typeface="Consolas"/>
+              </a:rPr>
+              <a:t>(grade-level units)</a:t>
             </a:r>
           </a:p>
         </p:txBody>
@@ -26817,61 +26841,61 @@
           <a:p>
             <a:pPr algn="l"/>
             <a:r>
-              <a:rPr sz="1100" b="0" i="0">
+              <a:rPr sz="1050" b="0" i="0">
                 <a:solidFill>
                   <a:srgbClr val="333333"/>
                 </a:solidFill>
                 <a:latin typeface="Consolas"/>
               </a:rPr>
-              <a:t>48. Sikeston R-6 (MO):  −0.275</a:t>
-            </a:r>
-          </a:p>
-          <a:p>
-            <a:pPr algn="l"/>
-            <a:r>
-              <a:rPr sz="1100" b="0" i="0">
+              <a:t>48  Sikeston R-6         −0.275</a:t>
+            </a:r>
+          </a:p>
+          <a:p>
+            <a:pPr algn="l"/>
+            <a:r>
+              <a:rPr sz="1050" b="0" i="0">
                 <a:solidFill>
                   <a:srgbClr val="333333"/>
                 </a:solidFill>
                 <a:latin typeface="Consolas"/>
               </a:rPr>
-              <a:t>47. Detroit DPSCD:  −0.259</a:t>
-            </a:r>
-          </a:p>
-          <a:p>
-            <a:pPr algn="l"/>
-            <a:r>
-              <a:rPr sz="1100" b="0" i="0">
+              <a:t>47  Detroit DPSCD        −0.259</a:t>
+            </a:r>
+          </a:p>
+          <a:p>
+            <a:pPr algn="l"/>
+            <a:r>
+              <a:rPr sz="1050" b="0" i="0">
                 <a:solidFill>
                   <a:srgbClr val="333333"/>
                 </a:solidFill>
                 <a:latin typeface="Consolas"/>
               </a:rPr>
-              <a:t>46. Troy SD:                  −0.253 ◄</a:t>
-            </a:r>
-          </a:p>
-          <a:p>
-            <a:pPr algn="l"/>
-            <a:r>
-              <a:rPr sz="1100" b="0" i="0">
+              <a:t>46  Troy SD              −0.253  ◄</a:t>
+            </a:r>
+          </a:p>
+          <a:p>
+            <a:pPr algn="l"/>
+            <a:r>
+              <a:rPr sz="1050" b="0" i="0">
                 <a:solidFill>
                   <a:srgbClr val="333333"/>
                 </a:solidFill>
                 <a:latin typeface="Consolas"/>
               </a:rPr>
-              <a:t>45. Bethlehem Area SD: −0.246</a:t>
-            </a:r>
-          </a:p>
-          <a:p>
-            <a:pPr algn="l"/>
-            <a:r>
-              <a:rPr sz="1100" b="0" i="0">
+              <a:t>45  Bethlehem Area SD    −0.246</a:t>
+            </a:r>
+          </a:p>
+          <a:p>
+            <a:pPr algn="l"/>
+            <a:r>
+              <a:rPr sz="1050" b="0" i="0">
                 <a:solidFill>
                   <a:srgbClr val="333333"/>
                 </a:solidFill>
                 <a:latin typeface="Consolas"/>
               </a:rPr>
-              <a:t>44. West Bloomfield:    −0.243</a:t>
+              <a:t>44  West Bloomfield      −0.243</a:t>
             </a:r>
           </a:p>
         </p:txBody>
@@ -26935,61 +26959,61 @@
           <a:p>
             <a:pPr algn="l"/>
             <a:r>
-              <a:rPr sz="1100" b="0" i="0">
+              <a:rPr sz="1050" b="0" i="0">
                 <a:solidFill>
                   <a:srgbClr val="333333"/>
                 </a:solidFill>
                 <a:latin typeface="Consolas"/>
               </a:rPr>
-              <a:t>1.  Spring Branch ISD:  +0.284¹  (TX STR³⁶)</a:t>
-            </a:r>
-          </a:p>
-          <a:p>
-            <a:pPr algn="l"/>
-            <a:r>
-              <a:rPr sz="1100" b="0" i="0">
+              <a:t>1  Spring Branch ISD    +0.284  (TX STR³⁶)</a:t>
+            </a:r>
+          </a:p>
+          <a:p>
+            <a:pPr algn="l"/>
+            <a:r>
+              <a:rPr sz="1050" b="0" i="0">
                 <a:solidFill>
                   <a:srgbClr val="333333"/>
                 </a:solidFill>
                 <a:latin typeface="Consolas"/>
               </a:rPr>
-              <a:t>2.  Palo Alto USD:           +0.132¹  (ESRI³⁵)</a:t>
-            </a:r>
-          </a:p>
-          <a:p>
-            <a:pPr algn="l"/>
-            <a:r>
-              <a:rPr sz="1100" b="0" i="0">
+              <a:t>2  Palo Alto USD        +0.132  (ESRI³⁵)</a:t>
+            </a:r>
+          </a:p>
+          <a:p>
+            <a:pPr algn="l"/>
+            <a:r>
+              <a:rPr sz="1050" b="0" i="0">
                 <a:solidFill>
                   <a:srgbClr val="333333"/>
                 </a:solidFill>
                 <a:latin typeface="Consolas"/>
               </a:rPr>
-              <a:t>3.  West Baton Rouge:  +0.132¹  (W&amp;W³⁷)</a:t>
-            </a:r>
-          </a:p>
-          <a:p>
-            <a:pPr algn="l"/>
-            <a:r>
-              <a:rPr sz="1100" b="0" i="0">
+              <a:t>3  West Baton Rouge     +0.132  (W&amp;W³⁷)</a:t>
+            </a:r>
+          </a:p>
+          <a:p>
+            <a:pPr algn="l"/>
+            <a:r>
+              <a:rPr sz="1050" b="0" i="0">
                 <a:solidFill>
                   <a:srgbClr val="333333"/>
                 </a:solidFill>
                 <a:latin typeface="Consolas"/>
               </a:rPr>
-              <a:t>4.  Johnson City TN:     +0.121¹  (TN HQIM³⁹)</a:t>
-            </a:r>
-          </a:p>
-          <a:p>
-            <a:pPr algn="l"/>
-            <a:r>
-              <a:rPr sz="1100" b="0" i="0">
+              <a:t>4  Johnson City TN      +0.121  (TN HQIM³⁹)</a:t>
+            </a:r>
+          </a:p>
+          <a:p>
+            <a:pPr algn="l"/>
+            <a:r>
+              <a:rPr sz="1050" b="0" i="0">
                 <a:solidFill>
                   <a:srgbClr val="333333"/>
                 </a:solidFill>
                 <a:latin typeface="Consolas"/>
               </a:rPr>
-              <a:t>5.  Frisco ISD:                  +0.097¹  (BL; TX state lifted⁶)</a:t>
+              <a:t>5  Frisco ISD           +0.097  (BL)</a:t>
             </a:r>
           </a:p>
         </p:txBody>
@@ -27592,7 +27616,7 @@
                 </a:solidFill>
                 <a:latin typeface="Consolas"/>
               </a:rPr>
-              <a:t>Spring Branch ISD     +0.284  (TX STR³⁶)</a:t>
+              <a:t>Spring Branch     +0.284   TX STR³⁶</a:t>
             </a:r>
           </a:p>
           <a:p>
@@ -27604,7 +27628,7 @@
                 </a:solidFill>
                 <a:latin typeface="Consolas"/>
               </a:rPr>
-              <a:t>Palo Alto USD              +0.132  (ESRI³⁵, post-Calkins)</a:t>
+              <a:t>Palo Alto USD     +0.132   ESRI³⁵</a:t>
             </a:r>
           </a:p>
           <a:p>
@@ -27616,7 +27640,7 @@
                 </a:solidFill>
                 <a:latin typeface="Consolas"/>
               </a:rPr>
-              <a:t>West Baton Rouge   +0.132  (W&amp;W + Fundations³⁷)</a:t>
+              <a:t>West Baton Rouge  +0.132   W&amp;W³⁷</a:t>
             </a:r>
           </a:p>
           <a:p>
@@ -27628,7 +27652,7 @@
                 </a:solidFill>
                 <a:latin typeface="Consolas"/>
               </a:rPr>
-              <a:t>Johnson City TN          +0.121  (TN HQIM³⁹)</a:t>
+              <a:t>Johnson City TN   +0.121   TN HQIM³⁹</a:t>
             </a:r>
           </a:p>
           <a:p>
@@ -27869,7 +27893,7 @@
                 </a:solidFill>
                 <a:latin typeface="Consolas"/>
               </a:rPr>
-              <a:t>Frisco ISD                       +0.097  (BL)</a:t>
+              <a:t>Frisco ISD        +0.097   BL</a:t>
             </a:r>
           </a:p>
           <a:p>
@@ -27881,7 +27905,7 @@
                 </a:solidFill>
                 <a:latin typeface="Consolas"/>
               </a:rPr>
-              <a:t>Milpitas USD                   +0.090  (Benchmark)</a:t>
+              <a:t>Milpitas USD      +0.090   Benchmark</a:t>
             </a:r>
           </a:p>
           <a:p>
@@ -27893,7 +27917,7 @@
                 </a:solidFill>
                 <a:latin typeface="Consolas"/>
               </a:rPr>
-              <a:t>Issaquah SD                    +0.087  (Benchmark '24)</a:t>
+              <a:t>Issaquah SD       +0.087   Benchmark '24</a:t>
             </a:r>
           </a:p>
           <a:p>
@@ -27905,7 +27929,7 @@
                 </a:solidFill>
                 <a:latin typeface="Consolas"/>
               </a:rPr>
-              <a:t>Dublin USD                       +0.084  (Benchmark+Heggerty)</a:t>
+              <a:t>Dublin USD        +0.084   Benchmark+Heggerty</a:t>
             </a:r>
           </a:p>
           <a:p>
@@ -27917,7 +27941,7 @@
                 </a:solidFill>
                 <a:latin typeface="Consolas"/>
               </a:rPr>
-              <a:t>Coppell ISD                     +0.068  (BL)</a:t>
+              <a:t>Coppell ISD       +0.068   BL</a:t>
             </a:r>
           </a:p>
           <a:p>
@@ -27929,7 +27953,7 @@
                 </a:solidFill>
                 <a:latin typeface="Consolas"/>
               </a:rPr>
-              <a:t>Princeton PS                   +0.060  (NJ affluent, BL?)</a:t>
+              <a:t>Princeton PS      +0.060   NJ peer (BL?)</a:t>
             </a:r>
           </a:p>
           <a:p>
@@ -27953,7 +27977,7 @@
                 </a:solidFill>
                 <a:latin typeface="Consolas"/>
               </a:rPr>
-              <a:t>Mix of BL, Benchmark-Advance, and recently-adopted SoR.</a:t>
+              <a:t>Mix of BL, Benchmark, and recently-adopted SoR.</a:t>
             </a:r>
           </a:p>
         </p:txBody>
@@ -28599,97 +28623,97 @@
           <a:p>
             <a:pPr algn="l"/>
             <a:r>
-              <a:rPr sz="1150" b="0" i="0">
+              <a:rPr sz="1100" b="0" i="0">
                 <a:solidFill>
                   <a:srgbClr val="333333"/>
                 </a:solidFill>
                 <a:latin typeface="Consolas"/>
               </a:rPr>
-              <a:t>Bloomfield Hills:  +0.026 ← best</a:t>
-            </a:r>
-          </a:p>
-          <a:p>
-            <a:pPr algn="l"/>
-            <a:r>
-              <a:rPr sz="1150" b="0" i="0">
+              <a:t>Bloomfield Hills    +0.026   ← best</a:t>
+            </a:r>
+          </a:p>
+          <a:p>
+            <a:pPr algn="l"/>
+            <a:r>
+              <a:rPr sz="1100" b="0" i="0">
                 <a:solidFill>
                   <a:srgbClr val="333333"/>
                 </a:solidFill>
                 <a:latin typeface="Consolas"/>
               </a:rPr>
-              <a:t>Birmingham PS:    −0.017</a:t>
-            </a:r>
-          </a:p>
-          <a:p>
-            <a:pPr algn="l"/>
-            <a:r>
-              <a:rPr sz="1150" b="0" i="0">
+              <a:t>Birmingham PS       −0.017</a:t>
+            </a:r>
+          </a:p>
+          <a:p>
+            <a:pPr algn="l"/>
+            <a:r>
+              <a:rPr sz="1100" b="0" i="0">
                 <a:solidFill>
                   <a:srgbClr val="333333"/>
                 </a:solidFill>
                 <a:latin typeface="Consolas"/>
               </a:rPr>
-              <a:t>Walled Lake:           −0.089</a:t>
-            </a:r>
-          </a:p>
-          <a:p>
-            <a:pPr algn="l"/>
-            <a:r>
-              <a:rPr sz="1150" b="0" i="0">
+              <a:t>Walled Lake         −0.089</a:t>
+            </a:r>
+          </a:p>
+          <a:p>
+            <a:pPr algn="l"/>
+            <a:r>
+              <a:rPr sz="1100" b="0" i="0">
                 <a:solidFill>
                   <a:srgbClr val="333333"/>
                 </a:solidFill>
                 <a:latin typeface="Consolas"/>
               </a:rPr>
-              <a:t>Northville PS:         −0.087</a:t>
-            </a:r>
-          </a:p>
-          <a:p>
-            <a:pPr algn="l"/>
-            <a:r>
-              <a:rPr sz="1150" b="0" i="0">
+              <a:t>Northville PS       −0.087</a:t>
+            </a:r>
+          </a:p>
+          <a:p>
+            <a:pPr algn="l"/>
+            <a:r>
+              <a:rPr sz="1100" b="0" i="0">
                 <a:solidFill>
                   <a:srgbClr val="333333"/>
                 </a:solidFill>
                 <a:latin typeface="Consolas"/>
               </a:rPr>
-              <a:t>Novi CSD:                  −0.103  (49% Asian)</a:t>
-            </a:r>
-          </a:p>
-          <a:p>
-            <a:pPr algn="l"/>
-            <a:r>
-              <a:rPr sz="1150" b="0" i="0">
+              <a:t>Novi CSD            −0.103</a:t>
+            </a:r>
+          </a:p>
+          <a:p>
+            <a:pPr algn="l"/>
+            <a:r>
+              <a:rPr sz="1100" b="0" i="0">
                 <a:solidFill>
                   <a:srgbClr val="333333"/>
                 </a:solidFill>
                 <a:latin typeface="Consolas"/>
               </a:rPr>
-              <a:t>Rochester CSD:        −0.215</a:t>
-            </a:r>
-          </a:p>
-          <a:p>
-            <a:pPr algn="l"/>
-            <a:r>
-              <a:rPr sz="1150" b="0" i="0">
+              <a:t>Rochester CSD       −0.215</a:t>
+            </a:r>
+          </a:p>
+          <a:p>
+            <a:pPr algn="l"/>
+            <a:r>
+              <a:rPr sz="1100" b="0" i="0">
                 <a:solidFill>
                   <a:srgbClr val="333333"/>
                 </a:solidFill>
                 <a:latin typeface="Consolas"/>
               </a:rPr>
-              <a:t>West Bloomfield:    −0.243</a:t>
-            </a:r>
-          </a:p>
-          <a:p>
-            <a:pPr algn="l"/>
-            <a:r>
-              <a:rPr sz="1150" b="0" i="0">
+              <a:t>West Bloomfield     −0.243</a:t>
+            </a:r>
+          </a:p>
+          <a:p>
+            <a:pPr algn="l"/>
+            <a:r>
+              <a:rPr sz="1100" b="0" i="0">
                 <a:solidFill>
                   <a:srgbClr val="333333"/>
                 </a:solidFill>
                 <a:latin typeface="Consolas"/>
               </a:rPr>
-              <a:t>Troy SD:                    −0.253 ◄ worst</a:t>
+              <a:t>Troy SD             −0.253   ◄ worst</a:t>
             </a:r>
           </a:p>
         </p:txBody>
@@ -28753,61 +28777,61 @@
           <a:p>
             <a:pPr algn="l"/>
             <a:r>
-              <a:rPr sz="1250" b="0" i="0">
+              <a:rPr sz="1150" b="0" i="0">
                 <a:solidFill>
                   <a:srgbClr val="333333"/>
                 </a:solidFill>
                 <a:latin typeface="Consolas"/>
               </a:rPr>
-              <a:t>Birmingham (4% Asian):       75.4%</a:t>
-            </a:r>
-          </a:p>
-          <a:p>
-            <a:pPr algn="l"/>
-            <a:r>
-              <a:rPr sz="1250" b="0" i="0">
+              <a:t>Birmingham           75.4%   (4% Asian)</a:t>
+            </a:r>
+          </a:p>
+          <a:p>
+            <a:pPr algn="l"/>
+            <a:r>
+              <a:rPr sz="1150" b="0" i="0">
                 <a:solidFill>
                   <a:srgbClr val="333333"/>
                 </a:solidFill>
                 <a:latin typeface="Consolas"/>
               </a:rPr>
-              <a:t>Bloomfield Hills (9%):           70.6%</a:t>
-            </a:r>
-          </a:p>
-          <a:p>
-            <a:pPr algn="l"/>
-            <a:r>
-              <a:rPr sz="1250" b="0" i="0">
+              <a:t>Bloomfield Hills     70.6%   (9% Asian)</a:t>
+            </a:r>
+          </a:p>
+          <a:p>
+            <a:pPr algn="l"/>
+            <a:r>
+              <a:rPr sz="1150" b="0" i="0">
                 <a:solidFill>
                   <a:srgbClr val="333333"/>
                 </a:solidFill>
                 <a:latin typeface="Consolas"/>
               </a:rPr>
-              <a:t>Novi (49% Asian):                  68.5%</a:t>
-            </a:r>
-          </a:p>
-          <a:p>
-            <a:pPr algn="l"/>
-            <a:r>
-              <a:rPr sz="1250" b="0" i="0">
+              <a:t>Novi                 68.5%   (49% Asian)</a:t>
+            </a:r>
+          </a:p>
+          <a:p>
+            <a:pPr algn="l"/>
+            <a:r>
+              <a:rPr sz="1150" b="0" i="0">
                 <a:solidFill>
                   <a:srgbClr val="333333"/>
                 </a:solidFill>
                 <a:latin typeface="Consolas"/>
               </a:rPr>
-              <a:t>Rochester (17%):                    67.9%</a:t>
-            </a:r>
-          </a:p>
-          <a:p>
-            <a:pPr algn="l"/>
-            <a:r>
-              <a:rPr sz="1250" b="0" i="0">
+              <a:t>Rochester            67.9%   (17% Asian)</a:t>
+            </a:r>
+          </a:p>
+          <a:p>
+            <a:pPr algn="l"/>
+            <a:r>
+              <a:rPr sz="1150" b="0" i="0">
                 <a:solidFill>
                   <a:srgbClr val="333333"/>
                 </a:solidFill>
                 <a:latin typeface="Consolas"/>
               </a:rPr>
-              <a:t>Troy SD (37% Asian):           66.3% ◄</a:t>
+              <a:t>Troy SD              66.3%   (37% Asian)  ◄</a:t>
             </a:r>
           </a:p>
         </p:txBody>

</xml_diff>

<commit_message>
Clarify 28 vs 49 vs 50 district counts in deck appendix
The 28-district reference in slide 24 file map was vestigial from the
predecessor analysis. Fixed:
- Slide 19 (methodology): clarified 50 targeted, 49 with valid SEDA Δ;
  added a footer noting 20 (DOTR) and 28 (predecessor) for reference
- Slide 24 (file map): updated quantitative_analysis.md description
  from '28-district analysis + 6 charts' → 'Predecessor state-test
  analysis (28 districts on M-STEP/CAASPP/STAAR raw %)'
- reports/quantitative_analysis.md: prepended header note marking it
  as the predecessor; pointed at seda_2025_analysis.md as the
  authoritative current analysis

The four numbers in the project:
- 20 = ELA-relevant DOTR districts (Education Scorecard 2026)
- 28 = predecessor state-test analysis
- 49 = districts with valid SEDA pre/post-COVID Δ
- 50 = SEDA extraction targets (1 dropped for insufficient data)

Co-Authored-By: Claude Opus 4.7 (1M context) <noreply@anthropic.com>
</commit_message>
<xml_diff>
--- a/deck/Troy_K5_ELA_Executive_Summary_v4.pptx
+++ b/deck/Troy_K5_ELA_Executive_Summary_v4.pptx
@@ -17328,13 +17328,13 @@
           <a:p>
             <a:pPr algn="l"/>
             <a:r>
-              <a:rPr sz="1400" b="1" i="0">
+              <a:rPr sz="1300" b="1" i="0">
                 <a:solidFill>
                   <a:srgbClr val="1F3A5F"/>
                 </a:solidFill>
                 <a:latin typeface="Calibri"/>
               </a:rPr>
-              <a:t>District universe (N = 50)</a:t>
+              <a:t>District universe — 50 targeted, 49 with valid SEDA Δ</a:t>
             </a:r>
           </a:p>
         </p:txBody>
@@ -17348,34 +17348,34 @@
         <p:spPr>
           <a:xfrm>
             <a:off x="6400800" y="1325880"/>
-            <a:ext cx="5486400" cy="5120640"/>
-          </a:xfrm>
-          <a:prstGeom prst="rect">
-            <a:avLst/>
-          </a:prstGeom>
-          <a:noFill/>
-        </p:spPr>
-        <p:txBody>
-          <a:bodyPr wrap="square" lIns="0" rIns="0" tIns="0" bIns="0">
-            <a:spAutoFit/>
-          </a:bodyPr>
-          <a:lstStyle/>
-          <a:p>
-            <a:pPr algn="l"/>
-            <a:r>
-              <a:rPr sz="1100" b="0" i="0">
-                <a:solidFill>
-                  <a:srgbClr val="333333"/>
-                </a:solidFill>
-                <a:latin typeface="Calibri"/>
-              </a:rPr>
-              <a:t>•  Troy SD (subject district) + 7 MI affluent peers</a:t>
-            </a:r>
-          </a:p>
-          <a:p>
-            <a:pPr algn="l"/>
-            <a:r>
-              <a:rPr sz="1100" b="0" i="0">
+            <a:ext cx="5486400" cy="4572000"/>
+          </a:xfrm>
+          <a:prstGeom prst="rect">
+            <a:avLst/>
+          </a:prstGeom>
+          <a:noFill/>
+        </p:spPr>
+        <p:txBody>
+          <a:bodyPr wrap="square" lIns="0" rIns="0" tIns="0" bIns="0">
+            <a:spAutoFit/>
+          </a:bodyPr>
+          <a:lstStyle/>
+          <a:p>
+            <a:pPr algn="l"/>
+            <a:r>
+              <a:rPr sz="1050" b="0" i="0">
+                <a:solidFill>
+                  <a:srgbClr val="333333"/>
+                </a:solidFill>
+                <a:latin typeface="Calibri"/>
+              </a:rPr>
+              <a:t>•  Troy SD + 7 MI affluent peers</a:t>
+            </a:r>
+          </a:p>
+          <a:p>
+            <a:pPr algn="l"/>
+            <a:r>
+              <a:rPr sz="1050" b="0" i="0">
                 <a:solidFill>
                   <a:srgbClr val="333333"/>
                 </a:solidFill>
@@ -17387,19 +17387,7 @@
           <a:p>
             <a:pPr algn="l"/>
             <a:r>
-              <a:rPr sz="1100" b="0" i="0">
-                <a:solidFill>
-                  <a:srgbClr val="333333"/>
-                </a:solidFill>
-                <a:latin typeface="Calibri"/>
-              </a:rPr>
-              <a:t/>
-            </a:r>
-          </a:p>
-          <a:p>
-            <a:pPr algn="l"/>
-            <a:r>
-              <a:rPr sz="1100" b="0" i="0">
+              <a:rPr sz="1050" b="0" i="0">
                 <a:solidFill>
                   <a:srgbClr val="333333"/>
                 </a:solidFill>
@@ -17411,7 +17399,7 @@
           <a:p>
             <a:pPr algn="l"/>
             <a:r>
-              <a:rPr sz="1100" b="0" i="0">
+              <a:rPr sz="1050" b="0" i="0">
                 <a:solidFill>
                   <a:srgbClr val="333333"/>
                 </a:solidFill>
@@ -17423,19 +17411,7 @@
           <a:p>
             <a:pPr algn="l"/>
             <a:r>
-              <a:rPr sz="1100" b="0" i="0">
-                <a:solidFill>
-                  <a:srgbClr val="333333"/>
-                </a:solidFill>
-                <a:latin typeface="Calibri"/>
-              </a:rPr>
-              <a:t/>
-            </a:r>
-          </a:p>
-          <a:p>
-            <a:pPr algn="l"/>
-            <a:r>
-              <a:rPr sz="1100" b="0" i="0">
+              <a:rPr sz="1050" b="0" i="0">
                 <a:solidFill>
                   <a:srgbClr val="333333"/>
                 </a:solidFill>
@@ -17447,7 +17423,7 @@
           <a:p>
             <a:pPr algn="l"/>
             <a:r>
-              <a:rPr sz="1100" b="0" i="0">
+              <a:rPr sz="1050" b="0" i="0">
                 <a:solidFill>
                   <a:srgbClr val="333333"/>
                 </a:solidFill>
@@ -17459,19 +17435,7 @@
           <a:p>
             <a:pPr algn="l"/>
             <a:r>
-              <a:rPr sz="1100" b="0" i="0">
-                <a:solidFill>
-                  <a:srgbClr val="333333"/>
-                </a:solidFill>
-                <a:latin typeface="Calibri"/>
-              </a:rPr>
-              <a:t/>
-            </a:r>
-          </a:p>
-          <a:p>
-            <a:pPr algn="l"/>
-            <a:r>
-              <a:rPr sz="1100" b="0" i="0">
+              <a:rPr sz="1050" b="0" i="0">
                 <a:solidFill>
                   <a:srgbClr val="333333"/>
                 </a:solidFill>
@@ -17483,7 +17447,7 @@
           <a:p>
             <a:pPr algn="l"/>
             <a:r>
-              <a:rPr sz="1100" b="0" i="0">
+              <a:rPr sz="1050" b="0" i="0">
                 <a:solidFill>
                   <a:srgbClr val="333333"/>
                 </a:solidFill>
@@ -17495,43 +17459,19 @@
           <a:p>
             <a:pPr algn="l"/>
             <a:r>
-              <a:rPr sz="1100" b="0" i="0">
-                <a:solidFill>
-                  <a:srgbClr val="333333"/>
-                </a:solidFill>
-                <a:latin typeface="Calibri"/>
-              </a:rPr>
-              <a:t/>
-            </a:r>
-          </a:p>
-          <a:p>
-            <a:pPr algn="l"/>
-            <a:r>
-              <a:rPr sz="1100" b="0" i="0">
-                <a:solidFill>
-                  <a:srgbClr val="333333"/>
-                </a:solidFill>
-                <a:latin typeface="Calibri"/>
-              </a:rPr>
-              <a:t>•  Steubenville (OH gold standard)  + Detroit (MI in-state outperformer)</a:t>
-            </a:r>
-          </a:p>
-          <a:p>
-            <a:pPr algn="l"/>
-            <a:r>
-              <a:rPr sz="1100" b="0" i="0">
-                <a:solidFill>
-                  <a:srgbClr val="333333"/>
-                </a:solidFill>
-                <a:latin typeface="Calibri"/>
-              </a:rPr>
-              <a:t/>
-            </a:r>
-          </a:p>
-          <a:p>
-            <a:pPr algn="l"/>
-            <a:r>
-              <a:rPr sz="1100" b="0" i="0">
+              <a:rPr sz="1050" b="0" i="0">
+                <a:solidFill>
+                  <a:srgbClr val="333333"/>
+                </a:solidFill>
+                <a:latin typeface="Calibri"/>
+              </a:rPr>
+              <a:t>•  Steubenville (OH gold standard) + Detroit (MI in-state outperformer)</a:t>
+            </a:r>
+          </a:p>
+          <a:p>
+            <a:pPr algn="l"/>
+            <a:r>
+              <a:rPr sz="1050" b="0" i="0">
                 <a:solidFill>
                   <a:srgbClr val="333333"/>
                 </a:solidFill>
@@ -17545,6 +17485,76 @@
       <p:sp>
         <p:nvSpPr>
           <p:cNvPr id="13" name="TextBox 12"/>
+          <p:cNvSpPr txBox="1"/>
+          <p:nvPr/>
+        </p:nvSpPr>
+        <p:spPr>
+          <a:xfrm>
+            <a:off x="6400800" y="5852160"/>
+            <a:ext cx="5486400" cy="457200"/>
+          </a:xfrm>
+          <a:prstGeom prst="rect">
+            <a:avLst/>
+          </a:prstGeom>
+          <a:noFill/>
+        </p:spPr>
+        <p:txBody>
+          <a:bodyPr wrap="square" lIns="0" rIns="0" tIns="0" bIns="0">
+            <a:spAutoFit/>
+          </a:bodyPr>
+          <a:lstStyle/>
+          <a:p>
+            <a:pPr algn="l"/>
+            <a:r>
+              <a:rPr sz="1050" b="1" i="0">
+                <a:solidFill>
+                  <a:srgbClr val="1F3A5F"/>
+                </a:solidFill>
+                <a:latin typeface="Calibri"/>
+              </a:rPr>
+              <a:t>Counts referenced elsewhere in the deck:</a:t>
+            </a:r>
+          </a:p>
+        </p:txBody>
+      </p:sp>
+      <p:sp>
+        <p:nvSpPr>
+          <p:cNvPr id="14" name="TextBox 13"/>
+          <p:cNvSpPr txBox="1"/>
+          <p:nvPr/>
+        </p:nvSpPr>
+        <p:spPr>
+          <a:xfrm>
+            <a:off x="6400800" y="6080760"/>
+            <a:ext cx="5486400" cy="457200"/>
+          </a:xfrm>
+          <a:prstGeom prst="rect">
+            <a:avLst/>
+          </a:prstGeom>
+          <a:noFill/>
+        </p:spPr>
+        <p:txBody>
+          <a:bodyPr wrap="square" lIns="0" rIns="0" tIns="0" bIns="0">
+            <a:spAutoFit/>
+          </a:bodyPr>
+          <a:lstStyle/>
+          <a:p>
+            <a:pPr algn="l"/>
+            <a:r>
+              <a:rPr sz="950" b="0" i="1">
+                <a:solidFill>
+                  <a:srgbClr val="333333"/>
+                </a:solidFill>
+                <a:latin typeface="Calibri"/>
+              </a:rPr>
+              <a:t>20 = ELA-relevant DOTR districts (17 Math+Reading + 3 Reading-only).  28 = predecessor state-test analysis (raw % proficient on M-STEP/CAASPP/STAAR/etc., before SEDA expansion) — see reports/quantitative_analysis.md.</a:t>
+            </a:r>
+          </a:p>
+        </p:txBody>
+      </p:sp>
+      <p:sp>
+        <p:nvSpPr>
+          <p:cNvPr id="15" name="TextBox 14"/>
           <p:cNvSpPr txBox="1"/>
           <p:nvPr/>
         </p:nvSpPr>
@@ -17579,7 +17589,7 @@
       </p:sp>
       <p:sp>
         <p:nvSpPr>
-          <p:cNvPr id="14" name="TextBox 13"/>
+          <p:cNvPr id="16" name="TextBox 15"/>
           <p:cNvSpPr txBox="1"/>
           <p:nvPr/>
         </p:nvSpPr>
@@ -25357,7 +25367,7 @@
                 </a:solidFill>
                 <a:latin typeface="Calibri"/>
               </a:rPr>
-              <a:t>28-district analysis + 6 charts</a:t>
+              <a:t>Predecessor state-test analysis (28 districts on M-STEP/CAASPP/STAAR raw %)</a:t>
             </a:r>
           </a:p>
         </p:txBody>

</xml_diff>

<commit_message>
Tighten slide 7 + 18 formatting
- Slide 7 (DOTR comprehensive): convert the Math+Reading 17-district list from
  hand-padded monospace text to a real 3-column rect-table (District /
  Curriculum / Type). The Consolas-fallback drift that made row 1 look
  misaligned is gone; each cell is its own positioned text box, and the Type
  column is color-coded by category.
- Slide 18 (grade-level hypothesis): reduce whitespace. Hypothesis bar
  shrinks 0.85→0.7 in and goes inline label + body on one band. Both main
  boxes grow from 4.4 to 5.0 in (start at 1.85 instead of 2.05) so the
  curriculum-type table + Top-5 G5/G3 lists breathe. Confounders strip
  thinned from 0.7 to 0.45 in with the caveat inline.

Co-Authored-By: Claude Opus 4.7 (1M context) <noreply@anthropic.com>
</commit_message>
<xml_diff>
--- a/deck/Troy_K5_ELA_Executive_Summary_v4.pptx
+++ b/deck/Troy_K5_ELA_Executive_Summary_v4.pptx
@@ -9574,7 +9574,7 @@
         <p:spPr>
           <a:xfrm>
             <a:off x="365760" y="914400"/>
-            <a:ext cx="11430000" cy="777240"/>
+            <a:ext cx="11430000" cy="640080"/>
           </a:xfrm>
           <a:prstGeom prst="rect">
             <a:avLst/>
@@ -9617,23 +9617,23 @@
         </p:nvSpPr>
         <p:spPr>
           <a:xfrm>
-            <a:off x="548640" y="1005840"/>
-            <a:ext cx="10972800" cy="365760"/>
-          </a:xfrm>
-          <a:prstGeom prst="rect">
-            <a:avLst/>
-          </a:prstGeom>
-          <a:noFill/>
-        </p:spPr>
-        <p:txBody>
-          <a:bodyPr wrap="square" lIns="0" rIns="0" tIns="0" bIns="0">
-            <a:spAutoFit/>
-          </a:bodyPr>
-          <a:lstStyle/>
-          <a:p>
-            <a:pPr algn="l"/>
-            <a:r>
-              <a:rPr sz="1200" b="1" i="0">
+            <a:off x="548640" y="960120"/>
+            <a:ext cx="1828800" cy="274320"/>
+          </a:xfrm>
+          <a:prstGeom prst="rect">
+            <a:avLst/>
+          </a:prstGeom>
+          <a:noFill/>
+        </p:spPr>
+        <p:txBody>
+          <a:bodyPr wrap="square" lIns="0" rIns="0" tIns="0" bIns="0">
+            <a:spAutoFit/>
+          </a:bodyPr>
+          <a:lstStyle/>
+          <a:p>
+            <a:pPr algn="l"/>
+            <a:r>
+              <a:rPr sz="1150" b="1" i="0">
                 <a:solidFill>
                   <a:srgbClr val="1F3A5F"/>
                 </a:solidFill>
@@ -9652,23 +9652,23 @@
         </p:nvSpPr>
         <p:spPr>
           <a:xfrm>
-            <a:off x="548640" y="1325880"/>
-            <a:ext cx="10972800" cy="365760"/>
-          </a:xfrm>
-          <a:prstGeom prst="rect">
-            <a:avLst/>
-          </a:prstGeom>
-          <a:noFill/>
-        </p:spPr>
-        <p:txBody>
-          <a:bodyPr wrap="square" lIns="0" rIns="0" tIns="0" bIns="0">
-            <a:spAutoFit/>
-          </a:bodyPr>
-          <a:lstStyle/>
-          <a:p>
-            <a:pPr algn="l"/>
-            <a:r>
-              <a:rPr sz="1100" b="0" i="1">
+            <a:off x="548640" y="1207008"/>
+            <a:ext cx="11155680" cy="320040"/>
+          </a:xfrm>
+          <a:prstGeom prst="rect">
+            <a:avLst/>
+          </a:prstGeom>
+          <a:noFill/>
+        </p:spPr>
+        <p:txBody>
+          <a:bodyPr wrap="square" lIns="0" rIns="0" tIns="0" bIns="0">
+            <a:spAutoFit/>
+          </a:bodyPr>
+          <a:lstStyle/>
+          <a:p>
+            <a:pPr algn="l"/>
+            <a:r>
+              <a:rPr sz="1050" b="0" i="1">
                 <a:solidFill>
                   <a:srgbClr val="333333"/>
                 </a:solidFill>
@@ -9687,8 +9687,8 @@
         </p:nvSpPr>
         <p:spPr>
           <a:xfrm>
-            <a:off x="365760" y="1874519"/>
-            <a:ext cx="5669280" cy="4023360"/>
+            <a:off x="365760" y="1691640"/>
+            <a:ext cx="5669280" cy="4572000"/>
           </a:xfrm>
           <a:prstGeom prst="rect">
             <a:avLst/>
@@ -9731,7 +9731,7 @@
         </p:nvSpPr>
         <p:spPr>
           <a:xfrm>
-            <a:off x="502920" y="1965960"/>
+            <a:off x="502920" y="1783080"/>
             <a:ext cx="5486400" cy="365760"/>
           </a:xfrm>
           <a:prstGeom prst="rect">
@@ -9766,8 +9766,8 @@
         </p:nvSpPr>
         <p:spPr>
           <a:xfrm>
-            <a:off x="502920" y="2377440"/>
-            <a:ext cx="5486400" cy="3383280"/>
+            <a:off x="502920" y="2194560"/>
+            <a:ext cx="5486400" cy="4023360"/>
           </a:xfrm>
           <a:prstGeom prst="rect">
             <a:avLst/>
@@ -9957,8 +9957,8 @@
         </p:nvSpPr>
         <p:spPr>
           <a:xfrm>
-            <a:off x="6172200" y="1874519"/>
-            <a:ext cx="5623560" cy="4023360"/>
+            <a:off x="6172200" y="1691640"/>
+            <a:ext cx="5623560" cy="4572000"/>
           </a:xfrm>
           <a:prstGeom prst="rect">
             <a:avLst/>
@@ -10001,7 +10001,7 @@
         </p:nvSpPr>
         <p:spPr>
           <a:xfrm>
-            <a:off x="6309360" y="1965960"/>
+            <a:off x="6309360" y="1783080"/>
             <a:ext cx="5486400" cy="365760"/>
           </a:xfrm>
           <a:prstGeom prst="rect">
@@ -10036,8 +10036,8 @@
         </p:nvSpPr>
         <p:spPr>
           <a:xfrm>
-            <a:off x="6309360" y="2377440"/>
-            <a:ext cx="5486400" cy="3383280"/>
+            <a:off x="6309360" y="2194560"/>
+            <a:ext cx="5486400" cy="4023360"/>
           </a:xfrm>
           <a:prstGeom prst="rect">
             <a:avLst/>
@@ -10239,8 +10239,8 @@
         </p:nvSpPr>
         <p:spPr>
           <a:xfrm>
-            <a:off x="365760" y="6035040"/>
-            <a:ext cx="11430000" cy="640080"/>
+            <a:off x="365760" y="6355080"/>
+            <a:ext cx="11430000" cy="411480"/>
           </a:xfrm>
           <a:prstGeom prst="rect">
             <a:avLst/>
@@ -10283,29 +10283,29 @@
         </p:nvSpPr>
         <p:spPr>
           <a:xfrm>
-            <a:off x="502920" y="6126480"/>
-            <a:ext cx="10972800" cy="274320"/>
-          </a:xfrm>
-          <a:prstGeom prst="rect">
-            <a:avLst/>
-          </a:prstGeom>
-          <a:noFill/>
-        </p:spPr>
-        <p:txBody>
-          <a:bodyPr wrap="square" lIns="0" rIns="0" tIns="0" bIns="0">
-            <a:spAutoFit/>
-          </a:bodyPr>
-          <a:lstStyle/>
-          <a:p>
-            <a:pPr algn="l"/>
-            <a:r>
-              <a:rPr sz="1100" b="1" i="0">
+            <a:off x="502920" y="6400800"/>
+            <a:ext cx="2560320" cy="274320"/>
+          </a:xfrm>
+          <a:prstGeom prst="rect">
+            <a:avLst/>
+          </a:prstGeom>
+          <a:noFill/>
+        </p:spPr>
+        <p:txBody>
+          <a:bodyPr wrap="square" lIns="0" rIns="0" tIns="0" bIns="0">
+            <a:spAutoFit/>
+          </a:bodyPr>
+          <a:lstStyle/>
+          <a:p>
+            <a:pPr algn="l"/>
+            <a:r>
+              <a:rPr sz="1000" b="1" i="0">
                 <a:solidFill>
                   <a:srgbClr val="B02121"/>
                 </a:solidFill>
                 <a:latin typeface="Calibri"/>
               </a:rPr>
-              <a:t>Confounders this data can't resolve</a:t>
+              <a:t>Confounders this data can't resolve:</a:t>
             </a:r>
           </a:p>
         </p:txBody>
@@ -10318,29 +10318,29 @@
         </p:nvSpPr>
         <p:spPr>
           <a:xfrm>
-            <a:off x="502920" y="6400800"/>
-            <a:ext cx="11247120" cy="365760"/>
-          </a:xfrm>
-          <a:prstGeom prst="rect">
-            <a:avLst/>
-          </a:prstGeom>
-          <a:noFill/>
-        </p:spPr>
-        <p:txBody>
-          <a:bodyPr wrap="square" lIns="0" rIns="0" tIns="0" bIns="0">
-            <a:spAutoFit/>
-          </a:bodyPr>
-          <a:lstStyle/>
-          <a:p>
-            <a:pPr algn="l"/>
-            <a:r>
-              <a:rPr sz="950" b="0" i="0">
-                <a:solidFill>
-                  <a:srgbClr val="333333"/>
-                </a:solidFill>
-                <a:latin typeface="Calibri"/>
-              </a:rPr>
-              <a:t>Cohort effects (today's G5 had K 5 years ago); test-scale differences across grades; COVID hit early grades hardest (K-1 missed in-person foundational year); small samples for SoR-recent and Mixed subcategories.</a:t>
+            <a:off x="3108960" y="6400800"/>
+            <a:ext cx="8686800" cy="320040"/>
+          </a:xfrm>
+          <a:prstGeom prst="rect">
+            <a:avLst/>
+          </a:prstGeom>
+          <a:noFill/>
+        </p:spPr>
+        <p:txBody>
+          <a:bodyPr wrap="square" lIns="0" rIns="0" tIns="0" bIns="0">
+            <a:spAutoFit/>
+          </a:bodyPr>
+          <a:lstStyle/>
+          <a:p>
+            <a:pPr algn="l"/>
+            <a:r>
+              <a:rPr sz="900" b="0" i="0">
+                <a:solidFill>
+                  <a:srgbClr val="333333"/>
+                </a:solidFill>
+                <a:latin typeface="Calibri"/>
+              </a:rPr>
+              <a:t>Cohort effects (G5 had K 5 yrs ago); cross-grade scale differences; COVID hit early grades hardest (K-1 missed foundational year); small SoR-recent/Mixed n.</a:t>
             </a:r>
           </a:p>
         </p:txBody>
@@ -30553,8 +30553,8 @@
         </p:nvSpPr>
         <p:spPr>
           <a:xfrm>
-            <a:off x="502920" y="1947672"/>
-            <a:ext cx="7315200" cy="274320"/>
+            <a:off x="502920" y="1947671"/>
+            <a:ext cx="7223759" cy="274320"/>
           </a:xfrm>
           <a:prstGeom prst="rect">
             <a:avLst/>
@@ -30588,8 +30588,43 @@
         </p:nvSpPr>
         <p:spPr>
           <a:xfrm>
-            <a:off x="502920" y="2331720"/>
-            <a:ext cx="7315200" cy="3840480"/>
+            <a:off x="502920" y="2331719"/>
+            <a:ext cx="1828800" cy="214884"/>
+          </a:xfrm>
+          <a:prstGeom prst="rect">
+            <a:avLst/>
+          </a:prstGeom>
+          <a:noFill/>
+        </p:spPr>
+        <p:txBody>
+          <a:bodyPr wrap="square" lIns="0" rIns="0" tIns="0" bIns="0">
+            <a:spAutoFit/>
+          </a:bodyPr>
+          <a:lstStyle/>
+          <a:p>
+            <a:pPr algn="l"/>
+            <a:r>
+              <a:rPr sz="900" b="1" i="0">
+                <a:solidFill>
+                  <a:srgbClr val="1F3A5F"/>
+                </a:solidFill>
+                <a:latin typeface="Calibri"/>
+              </a:rPr>
+              <a:t>East Hartford CT</a:t>
+            </a:r>
+          </a:p>
+        </p:txBody>
+      </p:sp>
+      <p:sp>
+        <p:nvSpPr>
+          <p:cNvPr id="12" name="TextBox 11"/>
+          <p:cNvSpPr txBox="1"/>
+          <p:nvPr/>
+        </p:nvSpPr>
+        <p:spPr>
+          <a:xfrm>
+            <a:off x="2331720" y="2331719"/>
+            <a:ext cx="4434840" cy="214884"/>
           </a:xfrm>
           <a:prstGeom prst="rect">
             <a:avLst/>
@@ -30608,11 +30643,104 @@
                 <a:solidFill>
                   <a:srgbClr val="333333"/>
                 </a:solidFill>
-                <a:latin typeface="Consolas"/>
-              </a:rPr>
-              <a:t>East Hartford CT      Fundations + Heggerty + Fundamentals Unl.   SoR</a:t>
-            </a:r>
-          </a:p>
+                <a:latin typeface="Calibri"/>
+              </a:rPr>
+              <a:t>Fundations + Heggerty + Fund. Unl.</a:t>
+            </a:r>
+          </a:p>
+        </p:txBody>
+      </p:sp>
+      <p:sp>
+        <p:nvSpPr>
+          <p:cNvPr id="13" name="TextBox 12"/>
+          <p:cNvSpPr txBox="1"/>
+          <p:nvPr/>
+        </p:nvSpPr>
+        <p:spPr>
+          <a:xfrm>
+            <a:off x="6766560" y="2331719"/>
+            <a:ext cx="1051560" cy="214884"/>
+          </a:xfrm>
+          <a:prstGeom prst="rect">
+            <a:avLst/>
+          </a:prstGeom>
+          <a:noFill/>
+        </p:spPr>
+        <p:txBody>
+          <a:bodyPr wrap="square" lIns="0" rIns="0" tIns="0" bIns="0">
+            <a:spAutoFit/>
+          </a:bodyPr>
+          <a:lstStyle/>
+          <a:p>
+            <a:pPr algn="l"/>
+            <a:r>
+              <a:rPr sz="900" b="1" i="0">
+                <a:solidFill>
+                  <a:srgbClr val="1F7A3D"/>
+                </a:solidFill>
+                <a:latin typeface="Calibri"/>
+              </a:rPr>
+              <a:t>SoR</a:t>
+            </a:r>
+          </a:p>
+        </p:txBody>
+      </p:sp>
+      <p:sp>
+        <p:nvSpPr>
+          <p:cNvPr id="14" name="TextBox 13"/>
+          <p:cNvSpPr txBox="1"/>
+          <p:nvPr/>
+        </p:nvSpPr>
+        <p:spPr>
+          <a:xfrm>
+            <a:off x="502920" y="2546603"/>
+            <a:ext cx="1828800" cy="214884"/>
+          </a:xfrm>
+          <a:prstGeom prst="rect">
+            <a:avLst/>
+          </a:prstGeom>
+          <a:noFill/>
+        </p:spPr>
+        <p:txBody>
+          <a:bodyPr wrap="square" lIns="0" rIns="0" tIns="0" bIns="0">
+            <a:spAutoFit/>
+          </a:bodyPr>
+          <a:lstStyle/>
+          <a:p>
+            <a:pPr algn="l"/>
+            <a:r>
+              <a:rPr sz="900" b="1" i="0">
+                <a:solidFill>
+                  <a:srgbClr val="1F3A5F"/>
+                </a:solidFill>
+                <a:latin typeface="Calibri"/>
+              </a:rPr>
+              <a:t>East Chicago IN</a:t>
+            </a:r>
+          </a:p>
+        </p:txBody>
+      </p:sp>
+      <p:sp>
+        <p:nvSpPr>
+          <p:cNvPr id="15" name="TextBox 14"/>
+          <p:cNvSpPr txBox="1"/>
+          <p:nvPr/>
+        </p:nvSpPr>
+        <p:spPr>
+          <a:xfrm>
+            <a:off x="2331720" y="2546603"/>
+            <a:ext cx="4434840" cy="214884"/>
+          </a:xfrm>
+          <a:prstGeom prst="rect">
+            <a:avLst/>
+          </a:prstGeom>
+          <a:noFill/>
+        </p:spPr>
+        <p:txBody>
+          <a:bodyPr wrap="square" lIns="0" rIns="0" tIns="0" bIns="0">
+            <a:spAutoFit/>
+          </a:bodyPr>
+          <a:lstStyle/>
           <a:p>
             <a:pPr algn="l"/>
             <a:r>
@@ -30620,11 +30748,104 @@
                 <a:solidFill>
                   <a:srgbClr val="333333"/>
                 </a:solidFill>
-                <a:latin typeface="Consolas"/>
-              </a:rPr>
-              <a:t>East Chicago IN       Heggerty + Reading Horizons + SoR coaches    SoR</a:t>
-            </a:r>
-          </a:p>
+                <a:latin typeface="Calibri"/>
+              </a:rPr>
+              <a:t>Heggerty + Reading Horizons + coaches</a:t>
+            </a:r>
+          </a:p>
+        </p:txBody>
+      </p:sp>
+      <p:sp>
+        <p:nvSpPr>
+          <p:cNvPr id="16" name="TextBox 15"/>
+          <p:cNvSpPr txBox="1"/>
+          <p:nvPr/>
+        </p:nvSpPr>
+        <p:spPr>
+          <a:xfrm>
+            <a:off x="6766560" y="2546603"/>
+            <a:ext cx="1051560" cy="214884"/>
+          </a:xfrm>
+          <a:prstGeom prst="rect">
+            <a:avLst/>
+          </a:prstGeom>
+          <a:noFill/>
+        </p:spPr>
+        <p:txBody>
+          <a:bodyPr wrap="square" lIns="0" rIns="0" tIns="0" bIns="0">
+            <a:spAutoFit/>
+          </a:bodyPr>
+          <a:lstStyle/>
+          <a:p>
+            <a:pPr algn="l"/>
+            <a:r>
+              <a:rPr sz="900" b="1" i="0">
+                <a:solidFill>
+                  <a:srgbClr val="1F7A3D"/>
+                </a:solidFill>
+                <a:latin typeface="Calibri"/>
+              </a:rPr>
+              <a:t>SoR</a:t>
+            </a:r>
+          </a:p>
+        </p:txBody>
+      </p:sp>
+      <p:sp>
+        <p:nvSpPr>
+          <p:cNvPr id="17" name="TextBox 16"/>
+          <p:cNvSpPr txBox="1"/>
+          <p:nvPr/>
+        </p:nvSpPr>
+        <p:spPr>
+          <a:xfrm>
+            <a:off x="502920" y="2761487"/>
+            <a:ext cx="1828800" cy="214884"/>
+          </a:xfrm>
+          <a:prstGeom prst="rect">
+            <a:avLst/>
+          </a:prstGeom>
+          <a:noFill/>
+        </p:spPr>
+        <p:txBody>
+          <a:bodyPr wrap="square" lIns="0" rIns="0" tIns="0" bIns="0">
+            <a:spAutoFit/>
+          </a:bodyPr>
+          <a:lstStyle/>
+          <a:p>
+            <a:pPr algn="l"/>
+            <a:r>
+              <a:rPr sz="900" b="1" i="0">
+                <a:solidFill>
+                  <a:srgbClr val="1F3A5F"/>
+                </a:solidFill>
+                <a:latin typeface="Calibri"/>
+              </a:rPr>
+              <a:t>Marion County KY</a:t>
+            </a:r>
+          </a:p>
+        </p:txBody>
+      </p:sp>
+      <p:sp>
+        <p:nvSpPr>
+          <p:cNvPr id="18" name="TextBox 17"/>
+          <p:cNvSpPr txBox="1"/>
+          <p:nvPr/>
+        </p:nvSpPr>
+        <p:spPr>
+          <a:xfrm>
+            <a:off x="2331720" y="2761487"/>
+            <a:ext cx="4434840" cy="214884"/>
+          </a:xfrm>
+          <a:prstGeom prst="rect">
+            <a:avLst/>
+          </a:prstGeom>
+          <a:noFill/>
+        </p:spPr>
+        <p:txBody>
+          <a:bodyPr wrap="square" lIns="0" rIns="0" tIns="0" bIns="0">
+            <a:spAutoFit/>
+          </a:bodyPr>
+          <a:lstStyle/>
           <a:p>
             <a:pPr algn="l"/>
             <a:r>
@@ -30632,11 +30853,104 @@
                 <a:solidFill>
                   <a:srgbClr val="333333"/>
                 </a:solidFill>
-                <a:latin typeface="Consolas"/>
-              </a:rPr>
-              <a:t>Marion County KY      Amplify CKLA + LETRS                         SoR</a:t>
-            </a:r>
-          </a:p>
+                <a:latin typeface="Calibri"/>
+              </a:rPr>
+              <a:t>Amplify CKLA + LETRS</a:t>
+            </a:r>
+          </a:p>
+        </p:txBody>
+      </p:sp>
+      <p:sp>
+        <p:nvSpPr>
+          <p:cNvPr id="19" name="TextBox 18"/>
+          <p:cNvSpPr txBox="1"/>
+          <p:nvPr/>
+        </p:nvSpPr>
+        <p:spPr>
+          <a:xfrm>
+            <a:off x="6766560" y="2761487"/>
+            <a:ext cx="1051560" cy="214884"/>
+          </a:xfrm>
+          <a:prstGeom prst="rect">
+            <a:avLst/>
+          </a:prstGeom>
+          <a:noFill/>
+        </p:spPr>
+        <p:txBody>
+          <a:bodyPr wrap="square" lIns="0" rIns="0" tIns="0" bIns="0">
+            <a:spAutoFit/>
+          </a:bodyPr>
+          <a:lstStyle/>
+          <a:p>
+            <a:pPr algn="l"/>
+            <a:r>
+              <a:rPr sz="900" b="1" i="0">
+                <a:solidFill>
+                  <a:srgbClr val="1F7A3D"/>
+                </a:solidFill>
+                <a:latin typeface="Calibri"/>
+              </a:rPr>
+              <a:t>SoR</a:t>
+            </a:r>
+          </a:p>
+        </p:txBody>
+      </p:sp>
+      <p:sp>
+        <p:nvSpPr>
+          <p:cNvPr id="20" name="TextBox 19"/>
+          <p:cNvSpPr txBox="1"/>
+          <p:nvPr/>
+        </p:nvSpPr>
+        <p:spPr>
+          <a:xfrm>
+            <a:off x="502920" y="2976371"/>
+            <a:ext cx="1828800" cy="214884"/>
+          </a:xfrm>
+          <a:prstGeom prst="rect">
+            <a:avLst/>
+          </a:prstGeom>
+          <a:noFill/>
+        </p:spPr>
+        <p:txBody>
+          <a:bodyPr wrap="square" lIns="0" rIns="0" tIns="0" bIns="0">
+            <a:spAutoFit/>
+          </a:bodyPr>
+          <a:lstStyle/>
+          <a:p>
+            <a:pPr algn="l"/>
+            <a:r>
+              <a:rPr sz="900" b="1" i="0">
+                <a:solidFill>
+                  <a:srgbClr val="1F3A5F"/>
+                </a:solidFill>
+                <a:latin typeface="Calibri"/>
+              </a:rPr>
+              <a:t>Baltimore City MD</a:t>
+            </a:r>
+          </a:p>
+        </p:txBody>
+      </p:sp>
+      <p:sp>
+        <p:nvSpPr>
+          <p:cNvPr id="21" name="TextBox 20"/>
+          <p:cNvSpPr txBox="1"/>
+          <p:nvPr/>
+        </p:nvSpPr>
+        <p:spPr>
+          <a:xfrm>
+            <a:off x="2331720" y="2976371"/>
+            <a:ext cx="4434840" cy="214884"/>
+          </a:xfrm>
+          <a:prstGeom prst="rect">
+            <a:avLst/>
+          </a:prstGeom>
+          <a:noFill/>
+        </p:spPr>
+        <p:txBody>
+          <a:bodyPr wrap="square" lIns="0" rIns="0" tIns="0" bIns="0">
+            <a:spAutoFit/>
+          </a:bodyPr>
+          <a:lstStyle/>
           <a:p>
             <a:pPr algn="l"/>
             <a:r>
@@ -30644,11 +30958,104 @@
                 <a:solidFill>
                   <a:srgbClr val="333333"/>
                 </a:solidFill>
-                <a:latin typeface="Consolas"/>
-              </a:rPr>
-              <a:t>Baltimore City MD     Wit &amp; Wisdom K-8 (2018-)                     SoR</a:t>
-            </a:r>
-          </a:p>
+                <a:latin typeface="Calibri"/>
+              </a:rPr>
+              <a:t>Wit &amp; Wisdom K-8 (2018-)</a:t>
+            </a:r>
+          </a:p>
+        </p:txBody>
+      </p:sp>
+      <p:sp>
+        <p:nvSpPr>
+          <p:cNvPr id="22" name="TextBox 21"/>
+          <p:cNvSpPr txBox="1"/>
+          <p:nvPr/>
+        </p:nvSpPr>
+        <p:spPr>
+          <a:xfrm>
+            <a:off x="6766560" y="2976371"/>
+            <a:ext cx="1051560" cy="214884"/>
+          </a:xfrm>
+          <a:prstGeom prst="rect">
+            <a:avLst/>
+          </a:prstGeom>
+          <a:noFill/>
+        </p:spPr>
+        <p:txBody>
+          <a:bodyPr wrap="square" lIns="0" rIns="0" tIns="0" bIns="0">
+            <a:spAutoFit/>
+          </a:bodyPr>
+          <a:lstStyle/>
+          <a:p>
+            <a:pPr algn="l"/>
+            <a:r>
+              <a:rPr sz="900" b="1" i="0">
+                <a:solidFill>
+                  <a:srgbClr val="1F7A3D"/>
+                </a:solidFill>
+                <a:latin typeface="Calibri"/>
+              </a:rPr>
+              <a:t>SoR</a:t>
+            </a:r>
+          </a:p>
+        </p:txBody>
+      </p:sp>
+      <p:sp>
+        <p:nvSpPr>
+          <p:cNvPr id="23" name="TextBox 22"/>
+          <p:cNvSpPr txBox="1"/>
+          <p:nvPr/>
+        </p:nvSpPr>
+        <p:spPr>
+          <a:xfrm>
+            <a:off x="502920" y="3191255"/>
+            <a:ext cx="1828800" cy="214884"/>
+          </a:xfrm>
+          <a:prstGeom prst="rect">
+            <a:avLst/>
+          </a:prstGeom>
+          <a:noFill/>
+        </p:spPr>
+        <p:txBody>
+          <a:bodyPr wrap="square" lIns="0" rIns="0" tIns="0" bIns="0">
+            <a:spAutoFit/>
+          </a:bodyPr>
+          <a:lstStyle/>
+          <a:p>
+            <a:pPr algn="l"/>
+            <a:r>
+              <a:rPr sz="900" b="1" i="0">
+                <a:solidFill>
+                  <a:srgbClr val="1F3A5F"/>
+                </a:solidFill>
+                <a:latin typeface="Calibri"/>
+              </a:rPr>
+              <a:t>Detroit DPSCD MI</a:t>
+            </a:r>
+          </a:p>
+        </p:txBody>
+      </p:sp>
+      <p:sp>
+        <p:nvSpPr>
+          <p:cNvPr id="24" name="TextBox 23"/>
+          <p:cNvSpPr txBox="1"/>
+          <p:nvPr/>
+        </p:nvSpPr>
+        <p:spPr>
+          <a:xfrm>
+            <a:off x="2331720" y="3191255"/>
+            <a:ext cx="4434840" cy="214884"/>
+          </a:xfrm>
+          <a:prstGeom prst="rect">
+            <a:avLst/>
+          </a:prstGeom>
+          <a:noFill/>
+        </p:spPr>
+        <p:txBody>
+          <a:bodyPr wrap="square" lIns="0" rIns="0" tIns="0" bIns="0">
+            <a:spAutoFit/>
+          </a:bodyPr>
+          <a:lstStyle/>
           <a:p>
             <a:pPr algn="l"/>
             <a:r>
@@ -30656,11 +31063,104 @@
                 <a:solidFill>
                   <a:srgbClr val="333333"/>
                 </a:solidFill>
-                <a:latin typeface="Consolas"/>
-              </a:rPr>
-              <a:t>Detroit DPSCD MI      EL Education K-5 (2018-)                     SoR</a:t>
-            </a:r>
-          </a:p>
+                <a:latin typeface="Calibri"/>
+              </a:rPr>
+              <a:t>EL Education K-5 (2018-)</a:t>
+            </a:r>
+          </a:p>
+        </p:txBody>
+      </p:sp>
+      <p:sp>
+        <p:nvSpPr>
+          <p:cNvPr id="25" name="TextBox 24"/>
+          <p:cNvSpPr txBox="1"/>
+          <p:nvPr/>
+        </p:nvSpPr>
+        <p:spPr>
+          <a:xfrm>
+            <a:off x="6766560" y="3191255"/>
+            <a:ext cx="1051560" cy="214884"/>
+          </a:xfrm>
+          <a:prstGeom prst="rect">
+            <a:avLst/>
+          </a:prstGeom>
+          <a:noFill/>
+        </p:spPr>
+        <p:txBody>
+          <a:bodyPr wrap="square" lIns="0" rIns="0" tIns="0" bIns="0">
+            <a:spAutoFit/>
+          </a:bodyPr>
+          <a:lstStyle/>
+          <a:p>
+            <a:pPr algn="l"/>
+            <a:r>
+              <a:rPr sz="900" b="1" i="0">
+                <a:solidFill>
+                  <a:srgbClr val="1F7A3D"/>
+                </a:solidFill>
+                <a:latin typeface="Calibri"/>
+              </a:rPr>
+              <a:t>SoR</a:t>
+            </a:r>
+          </a:p>
+        </p:txBody>
+      </p:sp>
+      <p:sp>
+        <p:nvSpPr>
+          <p:cNvPr id="26" name="TextBox 25"/>
+          <p:cNvSpPr txBox="1"/>
+          <p:nvPr/>
+        </p:nvSpPr>
+        <p:spPr>
+          <a:xfrm>
+            <a:off x="502920" y="3406139"/>
+            <a:ext cx="1828800" cy="214884"/>
+          </a:xfrm>
+          <a:prstGeom prst="rect">
+            <a:avLst/>
+          </a:prstGeom>
+          <a:noFill/>
+        </p:spPr>
+        <p:txBody>
+          <a:bodyPr wrap="square" lIns="0" rIns="0" tIns="0" bIns="0">
+            <a:spAutoFit/>
+          </a:bodyPr>
+          <a:lstStyle/>
+          <a:p>
+            <a:pPr algn="l"/>
+            <a:r>
+              <a:rPr sz="900" b="1" i="0">
+                <a:solidFill>
+                  <a:srgbClr val="1F3A5F"/>
+                </a:solidFill>
+                <a:latin typeface="Calibri"/>
+              </a:rPr>
+              <a:t>Starkville MS</a:t>
+            </a:r>
+          </a:p>
+        </p:txBody>
+      </p:sp>
+      <p:sp>
+        <p:nvSpPr>
+          <p:cNvPr id="27" name="TextBox 26"/>
+          <p:cNvSpPr txBox="1"/>
+          <p:nvPr/>
+        </p:nvSpPr>
+        <p:spPr>
+          <a:xfrm>
+            <a:off x="2331720" y="3406139"/>
+            <a:ext cx="4434840" cy="214884"/>
+          </a:xfrm>
+          <a:prstGeom prst="rect">
+            <a:avLst/>
+          </a:prstGeom>
+          <a:noFill/>
+        </p:spPr>
+        <p:txBody>
+          <a:bodyPr wrap="square" lIns="0" rIns="0" tIns="0" bIns="0">
+            <a:spAutoFit/>
+          </a:bodyPr>
+          <a:lstStyle/>
           <a:p>
             <a:pPr algn="l"/>
             <a:r>
@@ -30668,11 +31168,104 @@
                 <a:solidFill>
                   <a:srgbClr val="333333"/>
                 </a:solidFill>
-                <a:latin typeface="Consolas"/>
-              </a:rPr>
-              <a:t>Starkville MS         MS HQIM (BL→structured shift)                SoR</a:t>
-            </a:r>
-          </a:p>
+                <a:latin typeface="Calibri"/>
+              </a:rPr>
+              <a:t>MS HQIM (BL→structured shift)</a:t>
+            </a:r>
+          </a:p>
+        </p:txBody>
+      </p:sp>
+      <p:sp>
+        <p:nvSpPr>
+          <p:cNvPr id="28" name="TextBox 27"/>
+          <p:cNvSpPr txBox="1"/>
+          <p:nvPr/>
+        </p:nvSpPr>
+        <p:spPr>
+          <a:xfrm>
+            <a:off x="6766560" y="3406139"/>
+            <a:ext cx="1051560" cy="214884"/>
+          </a:xfrm>
+          <a:prstGeom prst="rect">
+            <a:avLst/>
+          </a:prstGeom>
+          <a:noFill/>
+        </p:spPr>
+        <p:txBody>
+          <a:bodyPr wrap="square" lIns="0" rIns="0" tIns="0" bIns="0">
+            <a:spAutoFit/>
+          </a:bodyPr>
+          <a:lstStyle/>
+          <a:p>
+            <a:pPr algn="l"/>
+            <a:r>
+              <a:rPr sz="900" b="1" i="0">
+                <a:solidFill>
+                  <a:srgbClr val="1F7A3D"/>
+                </a:solidFill>
+                <a:latin typeface="Calibri"/>
+              </a:rPr>
+              <a:t>SoR</a:t>
+            </a:r>
+          </a:p>
+        </p:txBody>
+      </p:sp>
+      <p:sp>
+        <p:nvSpPr>
+          <p:cNvPr id="29" name="TextBox 28"/>
+          <p:cNvSpPr txBox="1"/>
+          <p:nvPr/>
+        </p:nvSpPr>
+        <p:spPr>
+          <a:xfrm>
+            <a:off x="502920" y="3621023"/>
+            <a:ext cx="1828800" cy="214884"/>
+          </a:xfrm>
+          <a:prstGeom prst="rect">
+            <a:avLst/>
+          </a:prstGeom>
+          <a:noFill/>
+        </p:spPr>
+        <p:txBody>
+          <a:bodyPr wrap="square" lIns="0" rIns="0" tIns="0" bIns="0">
+            <a:spAutoFit/>
+          </a:bodyPr>
+          <a:lstStyle/>
+          <a:p>
+            <a:pPr algn="l"/>
+            <a:r>
+              <a:rPr sz="900" b="1" i="0">
+                <a:solidFill>
+                  <a:srgbClr val="1F3A5F"/>
+                </a:solidFill>
+                <a:latin typeface="Calibri"/>
+              </a:rPr>
+              <a:t>Pierre SD</a:t>
+            </a:r>
+          </a:p>
+        </p:txBody>
+      </p:sp>
+      <p:sp>
+        <p:nvSpPr>
+          <p:cNvPr id="30" name="TextBox 29"/>
+          <p:cNvSpPr txBox="1"/>
+          <p:nvPr/>
+        </p:nvSpPr>
+        <p:spPr>
+          <a:xfrm>
+            <a:off x="2331720" y="3621023"/>
+            <a:ext cx="4434840" cy="214884"/>
+          </a:xfrm>
+          <a:prstGeom prst="rect">
+            <a:avLst/>
+          </a:prstGeom>
+          <a:noFill/>
+        </p:spPr>
+        <p:txBody>
+          <a:bodyPr wrap="square" lIns="0" rIns="0" tIns="0" bIns="0">
+            <a:spAutoFit/>
+          </a:bodyPr>
+          <a:lstStyle/>
           <a:p>
             <a:pPr algn="l"/>
             <a:r>
@@ -30680,11 +31273,104 @@
                 <a:solidFill>
                   <a:srgbClr val="333333"/>
                 </a:solidFill>
-                <a:latin typeface="Consolas"/>
-              </a:rPr>
-              <a:t>Pierre SD             Open Court + OG + Heggerty + Barton          SoR</a:t>
-            </a:r>
-          </a:p>
+                <a:latin typeface="Calibri"/>
+              </a:rPr>
+              <a:t>Open Court + OG + Heggerty + Barton</a:t>
+            </a:r>
+          </a:p>
+        </p:txBody>
+      </p:sp>
+      <p:sp>
+        <p:nvSpPr>
+          <p:cNvPr id="31" name="TextBox 30"/>
+          <p:cNvSpPr txBox="1"/>
+          <p:nvPr/>
+        </p:nvSpPr>
+        <p:spPr>
+          <a:xfrm>
+            <a:off x="6766560" y="3621023"/>
+            <a:ext cx="1051560" cy="214884"/>
+          </a:xfrm>
+          <a:prstGeom prst="rect">
+            <a:avLst/>
+          </a:prstGeom>
+          <a:noFill/>
+        </p:spPr>
+        <p:txBody>
+          <a:bodyPr wrap="square" lIns="0" rIns="0" tIns="0" bIns="0">
+            <a:spAutoFit/>
+          </a:bodyPr>
+          <a:lstStyle/>
+          <a:p>
+            <a:pPr algn="l"/>
+            <a:r>
+              <a:rPr sz="900" b="1" i="0">
+                <a:solidFill>
+                  <a:srgbClr val="1F7A3D"/>
+                </a:solidFill>
+                <a:latin typeface="Calibri"/>
+              </a:rPr>
+              <a:t>SoR</a:t>
+            </a:r>
+          </a:p>
+        </p:txBody>
+      </p:sp>
+      <p:sp>
+        <p:nvSpPr>
+          <p:cNvPr id="32" name="TextBox 31"/>
+          <p:cNvSpPr txBox="1"/>
+          <p:nvPr/>
+        </p:nvSpPr>
+        <p:spPr>
+          <a:xfrm>
+            <a:off x="502920" y="3835907"/>
+            <a:ext cx="1828800" cy="214884"/>
+          </a:xfrm>
+          <a:prstGeom prst="rect">
+            <a:avLst/>
+          </a:prstGeom>
+          <a:noFill/>
+        </p:spPr>
+        <p:txBody>
+          <a:bodyPr wrap="square" lIns="0" rIns="0" tIns="0" bIns="0">
+            <a:spAutoFit/>
+          </a:bodyPr>
+          <a:lstStyle/>
+          <a:p>
+            <a:pPr algn="l"/>
+            <a:r>
+              <a:rPr sz="900" b="1" i="0">
+                <a:solidFill>
+                  <a:srgbClr val="1F3A5F"/>
+                </a:solidFill>
+                <a:latin typeface="Calibri"/>
+              </a:rPr>
+              <a:t>Johnson City TN</a:t>
+            </a:r>
+          </a:p>
+        </p:txBody>
+      </p:sp>
+      <p:sp>
+        <p:nvSpPr>
+          <p:cNvPr id="33" name="TextBox 32"/>
+          <p:cNvSpPr txBox="1"/>
+          <p:nvPr/>
+        </p:nvSpPr>
+        <p:spPr>
+          <a:xfrm>
+            <a:off x="2331720" y="3835907"/>
+            <a:ext cx="4434840" cy="214884"/>
+          </a:xfrm>
+          <a:prstGeom prst="rect">
+            <a:avLst/>
+          </a:prstGeom>
+          <a:noFill/>
+        </p:spPr>
+        <p:txBody>
+          <a:bodyPr wrap="square" lIns="0" rIns="0" tIns="0" bIns="0">
+            <a:spAutoFit/>
+          </a:bodyPr>
+          <a:lstStyle/>
           <a:p>
             <a:pPr algn="l"/>
             <a:r>
@@ -30692,11 +31378,104 @@
                 <a:solidFill>
                   <a:srgbClr val="333333"/>
                 </a:solidFill>
-                <a:latin typeface="Consolas"/>
-              </a:rPr>
-              <a:t>Johnson City TN       TN HQIM (SoR mandate)                        SoR</a:t>
-            </a:r>
-          </a:p>
+                <a:latin typeface="Calibri"/>
+              </a:rPr>
+              <a:t>TN HQIM (SoR mandate)</a:t>
+            </a:r>
+          </a:p>
+        </p:txBody>
+      </p:sp>
+      <p:sp>
+        <p:nvSpPr>
+          <p:cNvPr id="34" name="TextBox 33"/>
+          <p:cNvSpPr txBox="1"/>
+          <p:nvPr/>
+        </p:nvSpPr>
+        <p:spPr>
+          <a:xfrm>
+            <a:off x="6766560" y="3835907"/>
+            <a:ext cx="1051560" cy="214884"/>
+          </a:xfrm>
+          <a:prstGeom prst="rect">
+            <a:avLst/>
+          </a:prstGeom>
+          <a:noFill/>
+        </p:spPr>
+        <p:txBody>
+          <a:bodyPr wrap="square" lIns="0" rIns="0" tIns="0" bIns="0">
+            <a:spAutoFit/>
+          </a:bodyPr>
+          <a:lstStyle/>
+          <a:p>
+            <a:pPr algn="l"/>
+            <a:r>
+              <a:rPr sz="900" b="1" i="0">
+                <a:solidFill>
+                  <a:srgbClr val="1F7A3D"/>
+                </a:solidFill>
+                <a:latin typeface="Calibri"/>
+              </a:rPr>
+              <a:t>SoR</a:t>
+            </a:r>
+          </a:p>
+        </p:txBody>
+      </p:sp>
+      <p:sp>
+        <p:nvSpPr>
+          <p:cNvPr id="35" name="TextBox 34"/>
+          <p:cNvSpPr txBox="1"/>
+          <p:nvPr/>
+        </p:nvSpPr>
+        <p:spPr>
+          <a:xfrm>
+            <a:off x="502920" y="4050791"/>
+            <a:ext cx="1828800" cy="214884"/>
+          </a:xfrm>
+          <a:prstGeom prst="rect">
+            <a:avLst/>
+          </a:prstGeom>
+          <a:noFill/>
+        </p:spPr>
+        <p:txBody>
+          <a:bodyPr wrap="square" lIns="0" rIns="0" tIns="0" bIns="0">
+            <a:spAutoFit/>
+          </a:bodyPr>
+          <a:lstStyle/>
+          <a:p>
+            <a:pPr algn="l"/>
+            <a:r>
+              <a:rPr sz="900" b="1" i="0">
+                <a:solidFill>
+                  <a:srgbClr val="1F3A5F"/>
+                </a:solidFill>
+                <a:latin typeface="Calibri"/>
+              </a:rPr>
+              <a:t>Spring Branch TX</a:t>
+            </a:r>
+          </a:p>
+        </p:txBody>
+      </p:sp>
+      <p:sp>
+        <p:nvSpPr>
+          <p:cNvPr id="36" name="TextBox 35"/>
+          <p:cNvSpPr txBox="1"/>
+          <p:nvPr/>
+        </p:nvSpPr>
+        <p:spPr>
+          <a:xfrm>
+            <a:off x="2331720" y="4050791"/>
+            <a:ext cx="4434840" cy="214884"/>
+          </a:xfrm>
+          <a:prstGeom prst="rect">
+            <a:avLst/>
+          </a:prstGeom>
+          <a:noFill/>
+        </p:spPr>
+        <p:txBody>
+          <a:bodyPr wrap="square" lIns="0" rIns="0" tIns="0" bIns="0">
+            <a:spAutoFit/>
+          </a:bodyPr>
+          <a:lstStyle/>
           <a:p>
             <a:pPr algn="l"/>
             <a:r>
@@ -30704,11 +31483,104 @@
                 <a:solidFill>
                   <a:srgbClr val="333333"/>
                 </a:solidFill>
-                <a:latin typeface="Consolas"/>
-              </a:rPr>
-              <a:t>Spring Branch TX      TX STR framework                             SoR</a:t>
-            </a:r>
-          </a:p>
+                <a:latin typeface="Calibri"/>
+              </a:rPr>
+              <a:t>TX STR framework</a:t>
+            </a:r>
+          </a:p>
+        </p:txBody>
+      </p:sp>
+      <p:sp>
+        <p:nvSpPr>
+          <p:cNvPr id="37" name="TextBox 36"/>
+          <p:cNvSpPr txBox="1"/>
+          <p:nvPr/>
+        </p:nvSpPr>
+        <p:spPr>
+          <a:xfrm>
+            <a:off x="6766560" y="4050791"/>
+            <a:ext cx="1051560" cy="214884"/>
+          </a:xfrm>
+          <a:prstGeom prst="rect">
+            <a:avLst/>
+          </a:prstGeom>
+          <a:noFill/>
+        </p:spPr>
+        <p:txBody>
+          <a:bodyPr wrap="square" lIns="0" rIns="0" tIns="0" bIns="0">
+            <a:spAutoFit/>
+          </a:bodyPr>
+          <a:lstStyle/>
+          <a:p>
+            <a:pPr algn="l"/>
+            <a:r>
+              <a:rPr sz="900" b="1" i="0">
+                <a:solidFill>
+                  <a:srgbClr val="1F7A3D"/>
+                </a:solidFill>
+                <a:latin typeface="Calibri"/>
+              </a:rPr>
+              <a:t>SoR</a:t>
+            </a:r>
+          </a:p>
+        </p:txBody>
+      </p:sp>
+      <p:sp>
+        <p:nvSpPr>
+          <p:cNvPr id="38" name="TextBox 37"/>
+          <p:cNvSpPr txBox="1"/>
+          <p:nvPr/>
+        </p:nvSpPr>
+        <p:spPr>
+          <a:xfrm>
+            <a:off x="502920" y="4265675"/>
+            <a:ext cx="1828800" cy="214884"/>
+          </a:xfrm>
+          <a:prstGeom prst="rect">
+            <a:avLst/>
+          </a:prstGeom>
+          <a:noFill/>
+        </p:spPr>
+        <p:txBody>
+          <a:bodyPr wrap="square" lIns="0" rIns="0" tIns="0" bIns="0">
+            <a:spAutoFit/>
+          </a:bodyPr>
+          <a:lstStyle/>
+          <a:p>
+            <a:pPr algn="l"/>
+            <a:r>
+              <a:rPr sz="900" b="1" i="0">
+                <a:solidFill>
+                  <a:srgbClr val="1F3A5F"/>
+                </a:solidFill>
+                <a:latin typeface="Calibri"/>
+              </a:rPr>
+              <a:t>Fond du Lac WI</a:t>
+            </a:r>
+          </a:p>
+        </p:txBody>
+      </p:sp>
+      <p:sp>
+        <p:nvSpPr>
+          <p:cNvPr id="39" name="TextBox 38"/>
+          <p:cNvSpPr txBox="1"/>
+          <p:nvPr/>
+        </p:nvSpPr>
+        <p:spPr>
+          <a:xfrm>
+            <a:off x="2331720" y="4265675"/>
+            <a:ext cx="4434840" cy="214884"/>
+          </a:xfrm>
+          <a:prstGeom prst="rect">
+            <a:avLst/>
+          </a:prstGeom>
+          <a:noFill/>
+        </p:spPr>
+        <p:txBody>
+          <a:bodyPr wrap="square" lIns="0" rIns="0" tIns="0" bIns="0">
+            <a:spAutoFit/>
+          </a:bodyPr>
+          <a:lstStyle/>
           <a:p>
             <a:pPr algn="l"/>
             <a:r>
@@ -30716,11 +31588,104 @@
                 <a:solidFill>
                   <a:srgbClr val="333333"/>
                 </a:solidFill>
-                <a:latin typeface="Consolas"/>
-              </a:rPr>
-              <a:t>Fond du Lac WI        Amplify CKLA + DDI + UVA-PLE                 SoR</a:t>
-            </a:r>
-          </a:p>
+                <a:latin typeface="Calibri"/>
+              </a:rPr>
+              <a:t>Amplify CKLA + DDI + UVA-PLE</a:t>
+            </a:r>
+          </a:p>
+        </p:txBody>
+      </p:sp>
+      <p:sp>
+        <p:nvSpPr>
+          <p:cNvPr id="40" name="TextBox 39"/>
+          <p:cNvSpPr txBox="1"/>
+          <p:nvPr/>
+        </p:nvSpPr>
+        <p:spPr>
+          <a:xfrm>
+            <a:off x="6766560" y="4265675"/>
+            <a:ext cx="1051560" cy="214884"/>
+          </a:xfrm>
+          <a:prstGeom prst="rect">
+            <a:avLst/>
+          </a:prstGeom>
+          <a:noFill/>
+        </p:spPr>
+        <p:txBody>
+          <a:bodyPr wrap="square" lIns="0" rIns="0" tIns="0" bIns="0">
+            <a:spAutoFit/>
+          </a:bodyPr>
+          <a:lstStyle/>
+          <a:p>
+            <a:pPr algn="l"/>
+            <a:r>
+              <a:rPr sz="900" b="1" i="0">
+                <a:solidFill>
+                  <a:srgbClr val="1F7A3D"/>
+                </a:solidFill>
+                <a:latin typeface="Calibri"/>
+              </a:rPr>
+              <a:t>SoR</a:t>
+            </a:r>
+          </a:p>
+        </p:txBody>
+      </p:sp>
+      <p:sp>
+        <p:nvSpPr>
+          <p:cNvPr id="41" name="TextBox 40"/>
+          <p:cNvSpPr txBox="1"/>
+          <p:nvPr/>
+        </p:nvSpPr>
+        <p:spPr>
+          <a:xfrm>
+            <a:off x="502920" y="4480559"/>
+            <a:ext cx="1828800" cy="214884"/>
+          </a:xfrm>
+          <a:prstGeom prst="rect">
+            <a:avLst/>
+          </a:prstGeom>
+          <a:noFill/>
+        </p:spPr>
+        <p:txBody>
+          <a:bodyPr wrap="square" lIns="0" rIns="0" tIns="0" bIns="0">
+            <a:spAutoFit/>
+          </a:bodyPr>
+          <a:lstStyle/>
+          <a:p>
+            <a:pPr algn="l"/>
+            <a:r>
+              <a:rPr sz="900" b="1" i="0">
+                <a:solidFill>
+                  <a:srgbClr val="1F3A5F"/>
+                </a:solidFill>
+                <a:latin typeface="Calibri"/>
+              </a:rPr>
+              <a:t>Dover NH</a:t>
+            </a:r>
+          </a:p>
+        </p:txBody>
+      </p:sp>
+      <p:sp>
+        <p:nvSpPr>
+          <p:cNvPr id="42" name="TextBox 41"/>
+          <p:cNvSpPr txBox="1"/>
+          <p:nvPr/>
+        </p:nvSpPr>
+        <p:spPr>
+          <a:xfrm>
+            <a:off x="2331720" y="4480559"/>
+            <a:ext cx="4434840" cy="214884"/>
+          </a:xfrm>
+          <a:prstGeom prst="rect">
+            <a:avLst/>
+          </a:prstGeom>
+          <a:noFill/>
+        </p:spPr>
+        <p:txBody>
+          <a:bodyPr wrap="square" lIns="0" rIns="0" tIns="0" bIns="0">
+            <a:spAutoFit/>
+          </a:bodyPr>
+          <a:lstStyle/>
           <a:p>
             <a:pPr algn="l"/>
             <a:r>
@@ -30728,11 +31693,104 @@
                 <a:solidFill>
                   <a:srgbClr val="333333"/>
                 </a:solidFill>
-                <a:latin typeface="Consolas"/>
-              </a:rPr>
-              <a:t>Dover NH              Knowledge-building shift                     SoR-lean</a:t>
-            </a:r>
-          </a:p>
+                <a:latin typeface="Calibri"/>
+              </a:rPr>
+              <a:t>Knowledge-building shift</a:t>
+            </a:r>
+          </a:p>
+        </p:txBody>
+      </p:sp>
+      <p:sp>
+        <p:nvSpPr>
+          <p:cNvPr id="43" name="TextBox 42"/>
+          <p:cNvSpPr txBox="1"/>
+          <p:nvPr/>
+        </p:nvSpPr>
+        <p:spPr>
+          <a:xfrm>
+            <a:off x="6766560" y="4480559"/>
+            <a:ext cx="1051560" cy="214884"/>
+          </a:xfrm>
+          <a:prstGeom prst="rect">
+            <a:avLst/>
+          </a:prstGeom>
+          <a:noFill/>
+        </p:spPr>
+        <p:txBody>
+          <a:bodyPr wrap="square" lIns="0" rIns="0" tIns="0" bIns="0">
+            <a:spAutoFit/>
+          </a:bodyPr>
+          <a:lstStyle/>
+          <a:p>
+            <a:pPr algn="l"/>
+            <a:r>
+              <a:rPr sz="900" b="1" i="0">
+                <a:solidFill>
+                  <a:srgbClr val="CC6A11"/>
+                </a:solidFill>
+                <a:latin typeface="Calibri"/>
+              </a:rPr>
+              <a:t>SoR-lean</a:t>
+            </a:r>
+          </a:p>
+        </p:txBody>
+      </p:sp>
+      <p:sp>
+        <p:nvSpPr>
+          <p:cNvPr id="44" name="TextBox 43"/>
+          <p:cNvSpPr txBox="1"/>
+          <p:nvPr/>
+        </p:nvSpPr>
+        <p:spPr>
+          <a:xfrm>
+            <a:off x="502920" y="4695443"/>
+            <a:ext cx="1828800" cy="214884"/>
+          </a:xfrm>
+          <a:prstGeom prst="rect">
+            <a:avLst/>
+          </a:prstGeom>
+          <a:noFill/>
+        </p:spPr>
+        <p:txBody>
+          <a:bodyPr wrap="square" lIns="0" rIns="0" tIns="0" bIns="0">
+            <a:spAutoFit/>
+          </a:bodyPr>
+          <a:lstStyle/>
+          <a:p>
+            <a:pPr algn="l"/>
+            <a:r>
+              <a:rPr sz="900" b="1" i="0">
+                <a:solidFill>
+                  <a:srgbClr val="1F3A5F"/>
+                </a:solidFill>
+                <a:latin typeface="Calibri"/>
+              </a:rPr>
+              <a:t>Brandywine DE</a:t>
+            </a:r>
+          </a:p>
+        </p:txBody>
+      </p:sp>
+      <p:sp>
+        <p:nvSpPr>
+          <p:cNvPr id="45" name="TextBox 44"/>
+          <p:cNvSpPr txBox="1"/>
+          <p:nvPr/>
+        </p:nvSpPr>
+        <p:spPr>
+          <a:xfrm>
+            <a:off x="2331720" y="4695443"/>
+            <a:ext cx="4434840" cy="214884"/>
+          </a:xfrm>
+          <a:prstGeom prst="rect">
+            <a:avLst/>
+          </a:prstGeom>
+          <a:noFill/>
+        </p:spPr>
+        <p:txBody>
+          <a:bodyPr wrap="square" lIns="0" rIns="0" tIns="0" bIns="0">
+            <a:spAutoFit/>
+          </a:bodyPr>
+          <a:lstStyle/>
           <a:p>
             <a:pPr algn="l"/>
             <a:r>
@@ -30740,11 +31798,104 @@
                 <a:solidFill>
                   <a:srgbClr val="333333"/>
                 </a:solidFill>
-                <a:latin typeface="Consolas"/>
-              </a:rPr>
-              <a:t>Brandywine DE         Explicit phonics K-2                         SoR-lean</a:t>
-            </a:r>
-          </a:p>
+                <a:latin typeface="Calibri"/>
+              </a:rPr>
+              <a:t>Explicit phonics K-2</a:t>
+            </a:r>
+          </a:p>
+        </p:txBody>
+      </p:sp>
+      <p:sp>
+        <p:nvSpPr>
+          <p:cNvPr id="46" name="TextBox 45"/>
+          <p:cNvSpPr txBox="1"/>
+          <p:nvPr/>
+        </p:nvSpPr>
+        <p:spPr>
+          <a:xfrm>
+            <a:off x="6766560" y="4695443"/>
+            <a:ext cx="1051560" cy="214884"/>
+          </a:xfrm>
+          <a:prstGeom prst="rect">
+            <a:avLst/>
+          </a:prstGeom>
+          <a:noFill/>
+        </p:spPr>
+        <p:txBody>
+          <a:bodyPr wrap="square" lIns="0" rIns="0" tIns="0" bIns="0">
+            <a:spAutoFit/>
+          </a:bodyPr>
+          <a:lstStyle/>
+          <a:p>
+            <a:pPr algn="l"/>
+            <a:r>
+              <a:rPr sz="900" b="1" i="0">
+                <a:solidFill>
+                  <a:srgbClr val="CC6A11"/>
+                </a:solidFill>
+                <a:latin typeface="Calibri"/>
+              </a:rPr>
+              <a:t>SoR-lean</a:t>
+            </a:r>
+          </a:p>
+        </p:txBody>
+      </p:sp>
+      <p:sp>
+        <p:nvSpPr>
+          <p:cNvPr id="47" name="TextBox 46"/>
+          <p:cNvSpPr txBox="1"/>
+          <p:nvPr/>
+        </p:nvSpPr>
+        <p:spPr>
+          <a:xfrm>
+            <a:off x="502920" y="4910327"/>
+            <a:ext cx="1828800" cy="214884"/>
+          </a:xfrm>
+          <a:prstGeom prst="rect">
+            <a:avLst/>
+          </a:prstGeom>
+          <a:noFill/>
+        </p:spPr>
+        <p:txBody>
+          <a:bodyPr wrap="square" lIns="0" rIns="0" tIns="0" bIns="0">
+            <a:spAutoFit/>
+          </a:bodyPr>
+          <a:lstStyle/>
+          <a:p>
+            <a:pPr algn="l"/>
+            <a:r>
+              <a:rPr sz="900" b="1" i="0">
+                <a:solidFill>
+                  <a:srgbClr val="1F3A5F"/>
+                </a:solidFill>
+                <a:latin typeface="Calibri"/>
+              </a:rPr>
+              <a:t>Sikeston R-6 MO</a:t>
+            </a:r>
+          </a:p>
+        </p:txBody>
+      </p:sp>
+      <p:sp>
+        <p:nvSpPr>
+          <p:cNvPr id="48" name="TextBox 47"/>
+          <p:cNvSpPr txBox="1"/>
+          <p:nvPr/>
+        </p:nvSpPr>
+        <p:spPr>
+          <a:xfrm>
+            <a:off x="2331720" y="4910327"/>
+            <a:ext cx="4434840" cy="214884"/>
+          </a:xfrm>
+          <a:prstGeom prst="rect">
+            <a:avLst/>
+          </a:prstGeom>
+          <a:noFill/>
+        </p:spPr>
+        <p:txBody>
+          <a:bodyPr wrap="square" lIns="0" rIns="0" tIns="0" bIns="0">
+            <a:spAutoFit/>
+          </a:bodyPr>
+          <a:lstStyle/>
           <a:p>
             <a:pPr algn="l"/>
             <a:r>
@@ -30752,11 +31903,104 @@
                 <a:solidFill>
                   <a:srgbClr val="333333"/>
                 </a:solidFill>
-                <a:latin typeface="Consolas"/>
-              </a:rPr>
-              <a:t>Sikeston R-6 MO       Teacher-developed + state LETRS              SoR-lean</a:t>
-            </a:r>
-          </a:p>
+                <a:latin typeface="Calibri"/>
+              </a:rPr>
+              <a:t>Teacher-developed + state LETRS</a:t>
+            </a:r>
+          </a:p>
+        </p:txBody>
+      </p:sp>
+      <p:sp>
+        <p:nvSpPr>
+          <p:cNvPr id="49" name="TextBox 48"/>
+          <p:cNvSpPr txBox="1"/>
+          <p:nvPr/>
+        </p:nvSpPr>
+        <p:spPr>
+          <a:xfrm>
+            <a:off x="6766560" y="4910327"/>
+            <a:ext cx="1051560" cy="214884"/>
+          </a:xfrm>
+          <a:prstGeom prst="rect">
+            <a:avLst/>
+          </a:prstGeom>
+          <a:noFill/>
+        </p:spPr>
+        <p:txBody>
+          <a:bodyPr wrap="square" lIns="0" rIns="0" tIns="0" bIns="0">
+            <a:spAutoFit/>
+          </a:bodyPr>
+          <a:lstStyle/>
+          <a:p>
+            <a:pPr algn="l"/>
+            <a:r>
+              <a:rPr sz="900" b="1" i="0">
+                <a:solidFill>
+                  <a:srgbClr val="CC6A11"/>
+                </a:solidFill>
+                <a:latin typeface="Calibri"/>
+              </a:rPr>
+              <a:t>SoR-lean</a:t>
+            </a:r>
+          </a:p>
+        </p:txBody>
+      </p:sp>
+      <p:sp>
+        <p:nvSpPr>
+          <p:cNvPr id="50" name="TextBox 49"/>
+          <p:cNvSpPr txBox="1"/>
+          <p:nvPr/>
+        </p:nvSpPr>
+        <p:spPr>
+          <a:xfrm>
+            <a:off x="502920" y="5125211"/>
+            <a:ext cx="1828800" cy="214884"/>
+          </a:xfrm>
+          <a:prstGeom prst="rect">
+            <a:avLst/>
+          </a:prstGeom>
+          <a:noFill/>
+        </p:spPr>
+        <p:txBody>
+          <a:bodyPr wrap="square" lIns="0" rIns="0" tIns="0" bIns="0">
+            <a:spAutoFit/>
+          </a:bodyPr>
+          <a:lstStyle/>
+          <a:p>
+            <a:pPr algn="l"/>
+            <a:r>
+              <a:rPr sz="900" b="1" i="0">
+                <a:solidFill>
+                  <a:srgbClr val="1F3A5F"/>
+                </a:solidFill>
+                <a:latin typeface="Calibri"/>
+              </a:rPr>
+              <a:t>Atlanta APS GA</a:t>
+            </a:r>
+          </a:p>
+        </p:txBody>
+      </p:sp>
+      <p:sp>
+        <p:nvSpPr>
+          <p:cNvPr id="51" name="TextBox 50"/>
+          <p:cNvSpPr txBox="1"/>
+          <p:nvPr/>
+        </p:nvSpPr>
+        <p:spPr>
+          <a:xfrm>
+            <a:off x="2331720" y="5125211"/>
+            <a:ext cx="4434840" cy="214884"/>
+          </a:xfrm>
+          <a:prstGeom prst="rect">
+            <a:avLst/>
+          </a:prstGeom>
+          <a:noFill/>
+        </p:spPr>
+        <p:txBody>
+          <a:bodyPr wrap="square" lIns="0" rIns="0" tIns="0" bIns="0">
+            <a:spAutoFit/>
+          </a:bodyPr>
+          <a:lstStyle/>
           <a:p>
             <a:pPr algn="l"/>
             <a:r>
@@ -30764,11 +32008,104 @@
                 <a:solidFill>
                   <a:srgbClr val="333333"/>
                 </a:solidFill>
-                <a:latin typeface="Consolas"/>
-              </a:rPr>
-              <a:t>Atlanta APS GA        Benchmark + HMH (Phase 2 SoR pending)        SoR-trans.</a:t>
-            </a:r>
-          </a:p>
+                <a:latin typeface="Calibri"/>
+              </a:rPr>
+              <a:t>Benchmark + HMH (Phase 2 SoR)</a:t>
+            </a:r>
+          </a:p>
+        </p:txBody>
+      </p:sp>
+      <p:sp>
+        <p:nvSpPr>
+          <p:cNvPr id="52" name="TextBox 51"/>
+          <p:cNvSpPr txBox="1"/>
+          <p:nvPr/>
+        </p:nvSpPr>
+        <p:spPr>
+          <a:xfrm>
+            <a:off x="6766560" y="5125211"/>
+            <a:ext cx="1051560" cy="214884"/>
+          </a:xfrm>
+          <a:prstGeom prst="rect">
+            <a:avLst/>
+          </a:prstGeom>
+          <a:noFill/>
+        </p:spPr>
+        <p:txBody>
+          <a:bodyPr wrap="square" lIns="0" rIns="0" tIns="0" bIns="0">
+            <a:spAutoFit/>
+          </a:bodyPr>
+          <a:lstStyle/>
+          <a:p>
+            <a:pPr algn="l"/>
+            <a:r>
+              <a:rPr sz="900" b="1" i="0">
+                <a:solidFill>
+                  <a:srgbClr val="CC6A11"/>
+                </a:solidFill>
+                <a:latin typeface="Calibri"/>
+              </a:rPr>
+              <a:t>SoR-trans.</a:t>
+            </a:r>
+          </a:p>
+        </p:txBody>
+      </p:sp>
+      <p:sp>
+        <p:nvSpPr>
+          <p:cNvPr id="53" name="TextBox 52"/>
+          <p:cNvSpPr txBox="1"/>
+          <p:nvPr/>
+        </p:nvSpPr>
+        <p:spPr>
+          <a:xfrm>
+            <a:off x="502920" y="5340095"/>
+            <a:ext cx="1828800" cy="214884"/>
+          </a:xfrm>
+          <a:prstGeom prst="rect">
+            <a:avLst/>
+          </a:prstGeom>
+          <a:noFill/>
+        </p:spPr>
+        <p:txBody>
+          <a:bodyPr wrap="square" lIns="0" rIns="0" tIns="0" bIns="0">
+            <a:spAutoFit/>
+          </a:bodyPr>
+          <a:lstStyle/>
+          <a:p>
+            <a:pPr algn="l"/>
+            <a:r>
+              <a:rPr sz="900" b="1" i="0">
+                <a:solidFill>
+                  <a:srgbClr val="1F3A5F"/>
+                </a:solidFill>
+                <a:latin typeface="Calibri"/>
+              </a:rPr>
+              <a:t>Kuna Joint ID</a:t>
+            </a:r>
+          </a:p>
+        </p:txBody>
+      </p:sp>
+      <p:sp>
+        <p:nvSpPr>
+          <p:cNvPr id="54" name="TextBox 53"/>
+          <p:cNvSpPr txBox="1"/>
+          <p:nvPr/>
+        </p:nvSpPr>
+        <p:spPr>
+          <a:xfrm>
+            <a:off x="2331720" y="5340095"/>
+            <a:ext cx="4434840" cy="214884"/>
+          </a:xfrm>
+          <a:prstGeom prst="rect">
+            <a:avLst/>
+          </a:prstGeom>
+          <a:noFill/>
+        </p:spPr>
+        <p:txBody>
+          <a:bodyPr wrap="square" lIns="0" rIns="0" tIns="0" bIns="0">
+            <a:spAutoFit/>
+          </a:bodyPr>
+          <a:lstStyle/>
           <a:p>
             <a:pPr algn="l"/>
             <a:r>
@@ -30776,11 +32113,104 @@
                 <a:solidFill>
                   <a:srgbClr val="333333"/>
                 </a:solidFill>
-                <a:latin typeface="Consolas"/>
-              </a:rPr>
-              <a:t>Kuna Joint ID         HMH Into Reading planned 2026-27             SoR-future</a:t>
-            </a:r>
-          </a:p>
+                <a:latin typeface="Calibri"/>
+              </a:rPr>
+              <a:t>HMH Into Reading planned 2026-27</a:t>
+            </a:r>
+          </a:p>
+        </p:txBody>
+      </p:sp>
+      <p:sp>
+        <p:nvSpPr>
+          <p:cNvPr id="55" name="TextBox 54"/>
+          <p:cNvSpPr txBox="1"/>
+          <p:nvPr/>
+        </p:nvSpPr>
+        <p:spPr>
+          <a:xfrm>
+            <a:off x="6766560" y="5340095"/>
+            <a:ext cx="1051560" cy="214884"/>
+          </a:xfrm>
+          <a:prstGeom prst="rect">
+            <a:avLst/>
+          </a:prstGeom>
+          <a:noFill/>
+        </p:spPr>
+        <p:txBody>
+          <a:bodyPr wrap="square" lIns="0" rIns="0" tIns="0" bIns="0">
+            <a:spAutoFit/>
+          </a:bodyPr>
+          <a:lstStyle/>
+          <a:p>
+            <a:pPr algn="l"/>
+            <a:r>
+              <a:rPr sz="900" b="1" i="0">
+                <a:solidFill>
+                  <a:srgbClr val="1F3A5F"/>
+                </a:solidFill>
+                <a:latin typeface="Calibri"/>
+              </a:rPr>
+              <a:t>SoR-future</a:t>
+            </a:r>
+          </a:p>
+        </p:txBody>
+      </p:sp>
+      <p:sp>
+        <p:nvSpPr>
+          <p:cNvPr id="56" name="TextBox 55"/>
+          <p:cNvSpPr txBox="1"/>
+          <p:nvPr/>
+        </p:nvSpPr>
+        <p:spPr>
+          <a:xfrm>
+            <a:off x="502920" y="5554979"/>
+            <a:ext cx="1828800" cy="214884"/>
+          </a:xfrm>
+          <a:prstGeom prst="rect">
+            <a:avLst/>
+          </a:prstGeom>
+          <a:noFill/>
+        </p:spPr>
+        <p:txBody>
+          <a:bodyPr wrap="square" lIns="0" rIns="0" tIns="0" bIns="0">
+            <a:spAutoFit/>
+          </a:bodyPr>
+          <a:lstStyle/>
+          <a:p>
+            <a:pPr algn="l"/>
+            <a:r>
+              <a:rPr sz="900" b="1" i="0">
+                <a:solidFill>
+                  <a:srgbClr val="1F3A5F"/>
+                </a:solidFill>
+                <a:latin typeface="Calibri"/>
+              </a:rPr>
+              <a:t>College Comm. IA</a:t>
+            </a:r>
+          </a:p>
+        </p:txBody>
+      </p:sp>
+      <p:sp>
+        <p:nvSpPr>
+          <p:cNvPr id="57" name="TextBox 56"/>
+          <p:cNvSpPr txBox="1"/>
+          <p:nvPr/>
+        </p:nvSpPr>
+        <p:spPr>
+          <a:xfrm>
+            <a:off x="2331720" y="5554979"/>
+            <a:ext cx="4434840" cy="214884"/>
+          </a:xfrm>
+          <a:prstGeom prst="rect">
+            <a:avLst/>
+          </a:prstGeom>
+          <a:noFill/>
+        </p:spPr>
+        <p:txBody>
+          <a:bodyPr wrap="square" lIns="0" rIns="0" tIns="0" bIns="0">
+            <a:spAutoFit/>
+          </a:bodyPr>
+          <a:lstStyle/>
           <a:p>
             <a:pPr algn="l"/>
             <a:r>
@@ -30788,11 +32218,104 @@
                 <a:solidFill>
                   <a:srgbClr val="333333"/>
                 </a:solidFill>
-                <a:latin typeface="Consolas"/>
-              </a:rPr>
-              <a:t>College Community IA  MTSS focus (curriculum unclear)              Unclear</a:t>
-            </a:r>
-          </a:p>
+                <a:latin typeface="Calibri"/>
+              </a:rPr>
+              <a:t>MTSS focus (curriculum unclear)</a:t>
+            </a:r>
+          </a:p>
+        </p:txBody>
+      </p:sp>
+      <p:sp>
+        <p:nvSpPr>
+          <p:cNvPr id="58" name="TextBox 57"/>
+          <p:cNvSpPr txBox="1"/>
+          <p:nvPr/>
+        </p:nvSpPr>
+        <p:spPr>
+          <a:xfrm>
+            <a:off x="6766560" y="5554979"/>
+            <a:ext cx="1051560" cy="214884"/>
+          </a:xfrm>
+          <a:prstGeom prst="rect">
+            <a:avLst/>
+          </a:prstGeom>
+          <a:noFill/>
+        </p:spPr>
+        <p:txBody>
+          <a:bodyPr wrap="square" lIns="0" rIns="0" tIns="0" bIns="0">
+            <a:spAutoFit/>
+          </a:bodyPr>
+          <a:lstStyle/>
+          <a:p>
+            <a:pPr algn="l"/>
+            <a:r>
+              <a:rPr sz="900" b="1" i="0">
+                <a:solidFill>
+                  <a:srgbClr val="1F3A5F"/>
+                </a:solidFill>
+                <a:latin typeface="Calibri"/>
+              </a:rPr>
+              <a:t>Unclear</a:t>
+            </a:r>
+          </a:p>
+        </p:txBody>
+      </p:sp>
+      <p:sp>
+        <p:nvSpPr>
+          <p:cNvPr id="59" name="TextBox 58"/>
+          <p:cNvSpPr txBox="1"/>
+          <p:nvPr/>
+        </p:nvSpPr>
+        <p:spPr>
+          <a:xfrm>
+            <a:off x="502920" y="5769863"/>
+            <a:ext cx="1828800" cy="214884"/>
+          </a:xfrm>
+          <a:prstGeom prst="rect">
+            <a:avLst/>
+          </a:prstGeom>
+          <a:noFill/>
+        </p:spPr>
+        <p:txBody>
+          <a:bodyPr wrap="square" lIns="0" rIns="0" tIns="0" bIns="0">
+            <a:spAutoFit/>
+          </a:bodyPr>
+          <a:lstStyle/>
+          <a:p>
+            <a:pPr algn="l"/>
+            <a:r>
+              <a:rPr sz="900" b="1" i="0">
+                <a:solidFill>
+                  <a:srgbClr val="1F3A5F"/>
+                </a:solidFill>
+                <a:latin typeface="Calibri"/>
+              </a:rPr>
+              <a:t>Wayne County PS NC</a:t>
+            </a:r>
+          </a:p>
+        </p:txBody>
+      </p:sp>
+      <p:sp>
+        <p:nvSpPr>
+          <p:cNvPr id="60" name="TextBox 59"/>
+          <p:cNvSpPr txBox="1"/>
+          <p:nvPr/>
+        </p:nvSpPr>
+        <p:spPr>
+          <a:xfrm>
+            <a:off x="2331720" y="5769863"/>
+            <a:ext cx="4434840" cy="214884"/>
+          </a:xfrm>
+          <a:prstGeom prst="rect">
+            <a:avLst/>
+          </a:prstGeom>
+          <a:noFill/>
+        </p:spPr>
+        <p:txBody>
+          <a:bodyPr wrap="square" lIns="0" rIns="0" tIns="0" bIns="0">
+            <a:spAutoFit/>
+          </a:bodyPr>
+          <a:lstStyle/>
           <a:p>
             <a:pPr algn="l"/>
             <a:r>
@@ -30800,16 +32323,51 @@
                 <a:solidFill>
                   <a:srgbClr val="333333"/>
                 </a:solidFill>
-                <a:latin typeface="Consolas"/>
-              </a:rPr>
-              <a:t>Wayne County PS NC    Stayed BL                                    BL</a:t>
-            </a:r>
-          </a:p>
-        </p:txBody>
-      </p:sp>
-      <p:sp>
-        <p:nvSpPr>
-          <p:cNvPr id="12" name="Rectangle 11"/>
+                <a:latin typeface="Calibri"/>
+              </a:rPr>
+              <a:t>Stayed BL</a:t>
+            </a:r>
+          </a:p>
+        </p:txBody>
+      </p:sp>
+      <p:sp>
+        <p:nvSpPr>
+          <p:cNvPr id="61" name="TextBox 60"/>
+          <p:cNvSpPr txBox="1"/>
+          <p:nvPr/>
+        </p:nvSpPr>
+        <p:spPr>
+          <a:xfrm>
+            <a:off x="6766560" y="5769863"/>
+            <a:ext cx="1051560" cy="214884"/>
+          </a:xfrm>
+          <a:prstGeom prst="rect">
+            <a:avLst/>
+          </a:prstGeom>
+          <a:noFill/>
+        </p:spPr>
+        <p:txBody>
+          <a:bodyPr wrap="square" lIns="0" rIns="0" tIns="0" bIns="0">
+            <a:spAutoFit/>
+          </a:bodyPr>
+          <a:lstStyle/>
+          <a:p>
+            <a:pPr algn="l"/>
+            <a:r>
+              <a:rPr sz="900" b="1" i="0">
+                <a:solidFill>
+                  <a:srgbClr val="B02121"/>
+                </a:solidFill>
+                <a:latin typeface="Calibri"/>
+              </a:rPr>
+              <a:t>BL</a:t>
+            </a:r>
+          </a:p>
+        </p:txBody>
+      </p:sp>
+      <p:sp>
+        <p:nvSpPr>
+          <p:cNvPr id="62" name="Rectangle 61"/>
           <p:cNvSpPr/>
           <p:nvPr/>
         </p:nvSpPr>
@@ -30853,7 +32411,7 @@
       </p:sp>
       <p:sp>
         <p:nvSpPr>
-          <p:cNvPr id="13" name="Rectangle 12"/>
+          <p:cNvPr id="63" name="Rectangle 62"/>
           <p:cNvSpPr/>
           <p:nvPr/>
         </p:nvSpPr>
@@ -30897,7 +32455,7 @@
       </p:sp>
       <p:sp>
         <p:nvSpPr>
-          <p:cNvPr id="14" name="TextBox 13"/>
+          <p:cNvPr id="64" name="TextBox 63"/>
           <p:cNvSpPr txBox="1"/>
           <p:nvPr/>
         </p:nvSpPr>
@@ -30932,7 +32490,7 @@
       </p:sp>
       <p:sp>
         <p:nvSpPr>
-          <p:cNvPr id="15" name="TextBox 14"/>
+          <p:cNvPr id="65" name="TextBox 64"/>
           <p:cNvSpPr txBox="1"/>
           <p:nvPr/>
         </p:nvSpPr>
@@ -31087,7 +32645,7 @@
       </p:sp>
       <p:sp>
         <p:nvSpPr>
-          <p:cNvPr id="16" name="Rectangle 15"/>
+          <p:cNvPr id="66" name="Rectangle 65"/>
           <p:cNvSpPr/>
           <p:nvPr/>
         </p:nvSpPr>
@@ -31131,7 +32689,7 @@
       </p:sp>
       <p:sp>
         <p:nvSpPr>
-          <p:cNvPr id="17" name="TextBox 16"/>
+          <p:cNvPr id="67" name="TextBox 66"/>
           <p:cNvSpPr txBox="1"/>
           <p:nvPr/>
         </p:nvSpPr>
@@ -31166,7 +32724,7 @@
       </p:sp>
       <p:sp>
         <p:nvSpPr>
-          <p:cNvPr id="18" name="TextBox 17"/>
+          <p:cNvPr id="68" name="TextBox 67"/>
           <p:cNvSpPr txBox="1"/>
           <p:nvPr/>
         </p:nvSpPr>
@@ -31273,7 +32831,7 @@
       </p:sp>
       <p:sp>
         <p:nvSpPr>
-          <p:cNvPr id="19" name="TextBox 18"/>
+          <p:cNvPr id="69" name="TextBox 68"/>
           <p:cNvSpPr txBox="1"/>
           <p:nvPr/>
         </p:nvSpPr>
@@ -31308,7 +32866,7 @@
       </p:sp>
       <p:sp>
         <p:nvSpPr>
-          <p:cNvPr id="20" name="TextBox 19"/>
+          <p:cNvPr id="70" name="TextBox 69"/>
           <p:cNvSpPr txBox="1"/>
           <p:nvPr/>
         </p:nvSpPr>
@@ -31343,7 +32901,7 @@
       </p:sp>
       <p:sp>
         <p:nvSpPr>
-          <p:cNvPr id="21" name="TextBox 20"/>
+          <p:cNvPr id="71" name="TextBox 70"/>
           <p:cNvSpPr txBox="1"/>
           <p:nvPr/>
         </p:nvSpPr>

</xml_diff>